<commit_message>
Add the WIP-clearing case study to the report
Two slides on running a 200-lot backlog to completion: how long each
scheduling rule takes to clear it, and how the engineer headcount
changes which rule wins.

The result qualifies the report's first recommendation. Minimising
changeovers wins at 3 engineers and loses at 10, because never changing
a kit freezes the fleet in whatever configuration it happens to be in —
here QFN32 carries 38.6% of the work but sits on 22 of 100 sites, so
that one package alone needs 7 hours while the rest of the floor idles.
The recommendation slide now carries that condition.

Charts: clearing time by rule, completion curves, the headcount
crossover, and the per-package bottleneck under a frozen configuration.

Co-Authored-By: Claude Opus 5 <noreply@anthropic.com>
Claude-Session: https://claude.ai/code/session_01TrwTqMZ3kHRLL23LGZ4TZk
</commit_message>
<xml_diff>
--- a/docs/測試排程分析報告.pptx
+++ b/docs/測試排程分析報告.pptx
@@ -16,9 +16,11 @@
     <p:sldId id="264" r:id="rId10"/>
     <p:sldId id="265" r:id="rId11"/>
     <p:sldId id="266" r:id="rId12"/>
+    <p:sldId id="267" r:id="rId13"/>
+    <p:sldId id="268" r:id="rId14"/>
   </p:sldIdLst>
   <p:notesMasterIdLst>
-    <p:notesMasterId r:id="rId13"/>
+    <p:notesMasterId r:id="rId15"/>
   </p:notesMasterIdLst>
   <p:sldSz cx="12192000" cy="6858000"/>
   <p:notesSz cx="6858000" cy="12192000"/>
@@ -600,7 +602,7 @@
           <a:p>
             <a:r>
               <a:rPr lang="en-US" dirty="0"/>
-              <a:t>前兩項是純管理決策，今天就能改；第三項是人力預算；第四項需要 IT 或設備工程投入。</a:t>
+              <a:t>這是模擬產生的 200 批 WIP，結構比照現場：5 種封裝、8 種程式、小中大批 60/30/10。</a:t>
             </a:r>
             <a:endParaRPr lang="en-US" dirty="0"/>
           </a:p>
@@ -688,7 +690,7 @@
           <a:p>
             <a:r>
               <a:rPr lang="en-US" dirty="0"/>
-              <a:t>四個階段刻意分開，避免同時變動多個變數而無法歸因。最大的單一不確定性是換程式是否佔用工程師。</a:t>
+              <a:t>3 人時省改機的等工程師時間是 32 分，其他法則是 5,000~13,000 分；加上當機後，3 人除了省改機全部拖到 36~52 小時。</a:t>
             </a:r>
             <a:endParaRPr lang="en-US" dirty="0"/>
           </a:p>
@@ -712,6 +714,182 @@
             <a:fld id="{F7021451-1387-4CA6-816F-3879F97B5CBC}" type="slidenum">
               <a:rPr lang="en-US"/>
               <a:t>11</a:t>
+            </a:fld>
+            <a:endParaRPr lang="en-US"/>
+          </a:p>
+        </p:txBody>
+      </p:sp>
+    </p:spTree>
+    <p:extLst>
+      <p:ext uri="{BB962C8B-B14F-4D97-AF65-F5344CB8AC3E}">
+        <p14:creationId xmlns:p14="http://schemas.microsoft.com/office/powerpoint/2010/main" val="1024086991"/>
+      </p:ext>
+    </p:extLst>
+  </p:cSld>
+  <p:clrMapOvr>
+    <a:masterClrMapping/>
+  </p:clrMapOvr>
+</p:notes>
+</file>
+
+<file path=ppt/notesSlides/notesSlide12.xml><?xml version="1.0" encoding="utf-8"?>
+<p:notes xmlns:a="http://schemas.openxmlformats.org/drawingml/2006/main" xmlns:r="http://schemas.openxmlformats.org/officeDocument/2006/relationships" xmlns:p="http://schemas.openxmlformats.org/presentationml/2006/main">
+  <p:cSld>
+    <p:spTree>
+      <p:nvGrpSpPr>
+        <p:cNvPr id="1" name=""/>
+        <p:cNvGrpSpPr/>
+        <p:nvPr/>
+      </p:nvGrpSpPr>
+      <p:grpSpPr>
+        <a:xfrm>
+          <a:off x="0" y="0"/>
+          <a:ext cx="0" cy="0"/>
+          <a:chOff x="0" y="0"/>
+          <a:chExt cx="0" cy="0"/>
+        </a:xfrm>
+      </p:grpSpPr>
+      <p:sp>
+        <p:nvSpPr>
+          <p:cNvPr id="2" name="Slide Image Placeholder 1"/>
+          <p:cNvSpPr>
+            <a:spLocks noGrp="1" noRot="1" noChangeAspect="1"/>
+          </p:cNvSpPr>
+          <p:nvPr>
+            <p:ph type="sldImg"/>
+          </p:nvPr>
+        </p:nvSpPr>
+        <p:spPr/>
+      </p:sp>
+      <p:sp>
+        <p:nvSpPr>
+          <p:cNvPr id="3" name="Notes Placeholder 2"/>
+          <p:cNvSpPr>
+            <a:spLocks noGrp="1"/>
+          </p:cNvSpPr>
+          <p:nvPr>
+            <p:ph type="body" idx="1"/>
+          </p:nvPr>
+        </p:nvSpPr>
+        <p:spPr/>
+        <p:txBody>
+          <a:bodyPr/>
+          <a:lstStyle/>
+          <a:p>
+            <a:r>
+              <a:rPr lang="en-US" dirty="0"/>
+              <a:t>前兩項是純管理決策，今天就能改；第三項是人力預算；第四項需要 IT 或設備工程投入。</a:t>
+            </a:r>
+            <a:endParaRPr lang="en-US" dirty="0"/>
+          </a:p>
+        </p:txBody>
+      </p:sp>
+      <p:sp>
+        <p:nvSpPr>
+          <p:cNvPr id="4" name="Slide Number Placeholder 3"/>
+          <p:cNvSpPr>
+            <a:spLocks noGrp="1"/>
+          </p:cNvSpPr>
+          <p:nvPr>
+            <p:ph type="sldNum" sz="quarter" idx="10"/>
+          </p:nvPr>
+        </p:nvSpPr>
+        <p:spPr/>
+        <p:txBody>
+          <a:bodyPr/>
+          <a:lstStyle/>
+          <a:p>
+            <a:fld id="{F7021451-1387-4CA6-816F-3879F97B5CBC}" type="slidenum">
+              <a:rPr lang="en-US"/>
+              <a:t>12</a:t>
+            </a:fld>
+            <a:endParaRPr lang="en-US"/>
+          </a:p>
+        </p:txBody>
+      </p:sp>
+    </p:spTree>
+    <p:extLst>
+      <p:ext uri="{BB962C8B-B14F-4D97-AF65-F5344CB8AC3E}">
+        <p14:creationId xmlns:p14="http://schemas.microsoft.com/office/powerpoint/2010/main" val="1024086991"/>
+      </p:ext>
+    </p:extLst>
+  </p:cSld>
+  <p:clrMapOvr>
+    <a:masterClrMapping/>
+  </p:clrMapOvr>
+</p:notes>
+</file>
+
+<file path=ppt/notesSlides/notesSlide13.xml><?xml version="1.0" encoding="utf-8"?>
+<p:notes xmlns:a="http://schemas.openxmlformats.org/drawingml/2006/main" xmlns:r="http://schemas.openxmlformats.org/officeDocument/2006/relationships" xmlns:p="http://schemas.openxmlformats.org/presentationml/2006/main">
+  <p:cSld>
+    <p:spTree>
+      <p:nvGrpSpPr>
+        <p:cNvPr id="1" name=""/>
+        <p:cNvGrpSpPr/>
+        <p:nvPr/>
+      </p:nvGrpSpPr>
+      <p:grpSpPr>
+        <a:xfrm>
+          <a:off x="0" y="0"/>
+          <a:ext cx="0" cy="0"/>
+          <a:chOff x="0" y="0"/>
+          <a:chExt cx="0" cy="0"/>
+        </a:xfrm>
+      </p:grpSpPr>
+      <p:sp>
+        <p:nvSpPr>
+          <p:cNvPr id="2" name="Slide Image Placeholder 1"/>
+          <p:cNvSpPr>
+            <a:spLocks noGrp="1" noRot="1" noChangeAspect="1"/>
+          </p:cNvSpPr>
+          <p:nvPr>
+            <p:ph type="sldImg"/>
+          </p:nvPr>
+        </p:nvSpPr>
+        <p:spPr/>
+      </p:sp>
+      <p:sp>
+        <p:nvSpPr>
+          <p:cNvPr id="3" name="Notes Placeholder 2"/>
+          <p:cNvSpPr>
+            <a:spLocks noGrp="1"/>
+          </p:cNvSpPr>
+          <p:nvPr>
+            <p:ph type="body" idx="1"/>
+          </p:nvPr>
+        </p:nvSpPr>
+        <p:spPr/>
+        <p:txBody>
+          <a:bodyPr/>
+          <a:lstStyle/>
+          <a:p>
+            <a:r>
+              <a:rPr lang="en-US" dirty="0"/>
+              <a:t>四個階段刻意分開，避免同時變動多個變數而無法歸因。最大的單一不確定性是換程式是否佔用工程師。</a:t>
+            </a:r>
+            <a:endParaRPr lang="en-US" dirty="0"/>
+          </a:p>
+        </p:txBody>
+      </p:sp>
+      <p:sp>
+        <p:nvSpPr>
+          <p:cNvPr id="4" name="Slide Number Placeholder 3"/>
+          <p:cNvSpPr>
+            <a:spLocks noGrp="1"/>
+          </p:cNvSpPr>
+          <p:nvPr>
+            <p:ph type="sldNum" sz="quarter" idx="10"/>
+          </p:nvPr>
+        </p:nvSpPr>
+        <p:spPr/>
+        <p:txBody>
+          <a:bodyPr/>
+          <a:lstStyle/>
+          <a:p>
+            <a:fld id="{F7021451-1387-4CA6-816F-3879F97B5CBC}" type="slidenum">
+              <a:rPr lang="en-US"/>
+              <a:t>13</a:t>
             </a:fld>
             <a:endParaRPr lang="en-US"/>
           </a:p>
@@ -1955,13 +2133,6 @@
 <file path=ppt/slides/slide10.xml><?xml version="1.0" encoding="utf-8"?>
 <p:sld xmlns:a="http://schemas.openxmlformats.org/drawingml/2006/main" xmlns:r="http://schemas.openxmlformats.org/officeDocument/2006/relationships" xmlns:p="http://schemas.openxmlformats.org/presentationml/2006/main">
   <p:cSld name="Slide 10">
-    <p:bg>
-      <p:bgPr>
-        <a:solidFill>
-          <a:srgbClr val="0E1A3C"/>
-        </a:solidFill>
-      </p:bgPr>
-    </p:bg>
     <p:spTree>
       <p:nvGrpSpPr>
         <p:cNvPr id="1" name=""/>
@@ -2042,13 +2213,13 @@
             <a:r>
               <a:rPr lang="en-US" sz="3000" b="1" dirty="0">
                 <a:solidFill>
-                  <a:srgbClr val="FFFFFF"/>
+                  <a:srgbClr val="1E2761"/>
                 </a:solidFill>
                 <a:latin typeface="Cambria" pitchFamily="34" charset="0"/>
                 <a:ea typeface="Cambria" pitchFamily="34" charset="-122"/>
                 <a:cs typeface="Cambria" pitchFamily="34" charset="-120"/>
               </a:rPr>
-              <a:t>專業建議</a:t>
+              <a:t>實測案例：清空 200 批 WIP 要多久</a:t>
             </a:r>
             <a:endParaRPr lang="en-US" sz="3000" dirty="0"/>
           </a:p>
@@ -2063,7 +2234,7 @@
         <p:spPr>
           <a:xfrm>
             <a:off x="1143000" y="896112"/>
-            <a:ext cx="10424160" cy="365760"/>
+            <a:ext cx="10424160" cy="384048"/>
           </a:xfrm>
           <a:prstGeom prst="rect">
             <a:avLst/>
@@ -2081,40 +2252,88 @@
             <a:r>
               <a:rPr lang="en-US" sz="1350" dirty="0">
                 <a:solidFill>
-                  <a:srgbClr val="CADCFC"/>
-                </a:solidFill>
-                <a:latin typeface="Calibri" pitchFamily="34" charset="0"/>
-                <a:ea typeface="Calibri" pitchFamily="34" charset="-122"/>
-                <a:cs typeface="Calibri" pitchFamily="34" charset="-120"/>
-              </a:rPr>
-              <a:t>依「投入成本 → 效益」排序，前兩項不需任何資本支出</a:t>
+                  <a:srgbClr val="5A6785"/>
+                </a:solidFill>
+                <a:latin typeface="Calibri" pitchFamily="34" charset="0"/>
+                <a:ea typeface="Calibri" pitchFamily="34" charset="-122"/>
+                <a:cs typeface="Calibri" pitchFamily="34" charset="-120"/>
+              </a:rPr>
+              <a:t>把待測清單直接餵進模型，跑到最後一批做完為止——問的不再是「一天做多少」，而是「這堆貨要多久清光」</a:t>
             </a:r>
             <a:endParaRPr lang="en-US" sz="1350" dirty="0"/>
           </a:p>
         </p:txBody>
       </p:sp>
-      <p:sp>
-        <p:nvSpPr>
-          <p:cNvPr id="5" name="Shape 3"/>
+      <p:pic>
+        <p:nvPicPr>
+          <p:cNvPr id="5" name="Image 0" descr="charts/c_clear.png">    </p:cNvPr>
+          <p:cNvPicPr>
+            <a:picLocks noChangeAspect="1"/>
+          </p:cNvPicPr>
+          <p:nvPr/>
+        </p:nvPicPr>
+        <p:blipFill>
+          <a:blip r:embed="rId1"/>
+          <a:stretch>
+            <a:fillRect/>
+          </a:stretch>
+        </p:blipFill>
+        <p:spPr>
+          <a:xfrm>
+            <a:off x="566928" y="1371600"/>
+            <a:ext cx="6858000" cy="2500091"/>
+          </a:xfrm>
+          <a:prstGeom prst="rect">
+            <a:avLst/>
+          </a:prstGeom>
+        </p:spPr>
+      </p:pic>
+      <p:pic>
+        <p:nvPicPr>
+          <p:cNvPr id="6" name="Image 1" descr="charts/c_curve.png">    </p:cNvPr>
+          <p:cNvPicPr>
+            <a:picLocks noChangeAspect="1"/>
+          </p:cNvPicPr>
+          <p:nvPr/>
+        </p:nvPicPr>
+        <p:blipFill>
+          <a:blip r:embed="rId2"/>
+          <a:stretch>
+            <a:fillRect/>
+          </a:stretch>
+        </p:blipFill>
+        <p:spPr>
+          <a:xfrm>
+            <a:off x="7562088" y="1371600"/>
+            <a:ext cx="4059936" cy="2702480"/>
+          </a:xfrm>
+          <a:prstGeom prst="rect">
+            <a:avLst/>
+          </a:prstGeom>
+        </p:spPr>
+      </p:pic>
+      <p:sp>
+        <p:nvSpPr>
+          <p:cNvPr id="7" name="Shape 3"/>
           <p:cNvSpPr/>
           <p:nvPr/>
         </p:nvSpPr>
         <p:spPr>
           <a:xfrm>
-            <a:off x="566928" y="1417320"/>
-            <a:ext cx="11018520" cy="1051560"/>
+            <a:off x="566928" y="4206240"/>
+            <a:ext cx="5486400" cy="1828800"/>
           </a:xfrm>
           <a:prstGeom prst="roundRect">
             <a:avLst>
-              <a:gd name="adj" fmla="val 4348"/>
+              <a:gd name="adj" fmla="val 2500"/>
             </a:avLst>
           </a:prstGeom>
           <a:solidFill>
-            <a:srgbClr val="17254C"/>
+            <a:srgbClr val="F5F7FB"/>
           </a:solidFill>
           <a:ln w="12700">
             <a:solidFill>
-              <a:srgbClr val="17254C"/>
+              <a:srgbClr val="FFFFFF"/>
             </a:solidFill>
             <a:prstDash val="solid"/>
           </a:ln>
@@ -2122,24 +2341,24 @@
       </p:sp>
       <p:sp>
         <p:nvSpPr>
-          <p:cNvPr id="6" name="Shape 4"/>
+          <p:cNvPr id="8" name="Shape 4"/>
           <p:cNvSpPr/>
           <p:nvPr/>
         </p:nvSpPr>
         <p:spPr>
           <a:xfrm>
-            <a:off x="841248" y="1728216"/>
-            <a:ext cx="429768" cy="429768"/>
+            <a:off x="804672" y="4462272"/>
+            <a:ext cx="146304" cy="146304"/>
           </a:xfrm>
           <a:prstGeom prst="ellipse">
             <a:avLst/>
           </a:prstGeom>
           <a:solidFill>
-            <a:srgbClr val="0F7B6C"/>
+            <a:srgbClr val="1E2761"/>
           </a:solidFill>
           <a:ln w="12700">
             <a:solidFill>
-              <a:srgbClr val="0F7B6C"/>
+              <a:srgbClr val="1E2761"/>
             </a:solidFill>
             <a:prstDash val="solid"/>
           </a:ln>
@@ -2147,53 +2366,14 @@
       </p:sp>
       <p:sp>
         <p:nvSpPr>
-          <p:cNvPr id="7" name="Text 5"/>
-          <p:cNvSpPr txBox="1"/>
-          <p:nvPr/>
-        </p:nvSpPr>
-        <p:spPr>
-          <a:xfrm>
-            <a:off x="841248" y="1764792"/>
-            <a:ext cx="429768" cy="365760"/>
-          </a:xfrm>
-          <a:prstGeom prst="rect">
-            <a:avLst/>
-          </a:prstGeom>
-          <a:noFill/>
-          <a:ln/>
-        </p:spPr>
-        <p:txBody>
-          <a:bodyPr wrap="square" lIns="0" tIns="0" rIns="0" bIns="0" rtlCol="0" anchor="ctr"/>
-          <a:lstStyle/>
-          <a:p>
-            <a:pPr algn="ctr" indent="0" marL="0">
-              <a:buNone/>
-            </a:pPr>
-            <a:r>
-              <a:rPr lang="en-US" sz="1600" b="1" dirty="0">
-                <a:solidFill>
-                  <a:srgbClr val="FFFFFF"/>
-                </a:solidFill>
-                <a:latin typeface="Calibri" pitchFamily="34" charset="0"/>
-                <a:ea typeface="Calibri" pitchFamily="34" charset="-122"/>
-                <a:cs typeface="Calibri" pitchFamily="34" charset="-120"/>
-              </a:rPr>
-              <a:t>1</a:t>
-            </a:r>
-            <a:endParaRPr lang="en-US" sz="1600" dirty="0"/>
-          </a:p>
-        </p:txBody>
-      </p:sp>
-      <p:sp>
-        <p:nvSpPr>
-          <p:cNvPr id="8" name="Text 6"/>
-          <p:cNvSpPr txBox="1"/>
-          <p:nvPr/>
-        </p:nvSpPr>
-        <p:spPr>
-          <a:xfrm>
-            <a:off x="1481328" y="1600200"/>
-            <a:ext cx="6583680" cy="365760"/>
+          <p:cNvPr id="9" name="Text 5"/>
+          <p:cNvSpPr txBox="1"/>
+          <p:nvPr/>
+        </p:nvSpPr>
+        <p:spPr>
+          <a:xfrm>
+            <a:off x="1060704" y="4361688"/>
+            <a:ext cx="4754880" cy="329184"/>
           </a:xfrm>
           <a:prstGeom prst="rect">
             <a:avLst/>
@@ -2209,30 +2389,30 @@
               <a:buNone/>
             </a:pPr>
             <a:r>
-              <a:rPr lang="en-US" sz="1700" b="1" dirty="0">
-                <a:solidFill>
-                  <a:srgbClr val="FFFFFF"/>
-                </a:solidFill>
-                <a:latin typeface="Calibri" pitchFamily="34" charset="0"/>
-                <a:ea typeface="Calibri" pitchFamily="34" charset="-122"/>
-                <a:cs typeface="Calibri" pitchFamily="34" charset="-120"/>
-              </a:rPr>
-              <a:t>排程法則改為「省改機優先」</a:t>
-            </a:r>
-            <a:endParaRPr lang="en-US" sz="1700" dirty="0"/>
-          </a:p>
-        </p:txBody>
-      </p:sp>
-      <p:sp>
-        <p:nvSpPr>
-          <p:cNvPr id="9" name="Text 7"/>
-          <p:cNvSpPr txBox="1"/>
-          <p:nvPr/>
-        </p:nvSpPr>
-        <p:spPr>
-          <a:xfrm>
-            <a:off x="1481328" y="1984248"/>
-            <a:ext cx="6583680" cy="347472"/>
+              <a:rPr lang="en-US" sz="1450" b="1" dirty="0">
+                <a:solidFill>
+                  <a:srgbClr val="1E2761"/>
+                </a:solidFill>
+                <a:latin typeface="Calibri" pitchFamily="34" charset="0"/>
+                <a:ea typeface="Calibri" pitchFamily="34" charset="-122"/>
+                <a:cs typeface="Calibri" pitchFamily="34" charset="-120"/>
+              </a:rPr>
+              <a:t>這批貨的基本盤</a:t>
+            </a:r>
+            <a:endParaRPr lang="en-US" sz="1450" dirty="0"/>
+          </a:p>
+        </p:txBody>
+      </p:sp>
+      <p:sp>
+        <p:nvSpPr>
+          <p:cNvPr id="10" name="Text 6"/>
+          <p:cNvSpPr txBox="1"/>
+          <p:nvPr/>
+        </p:nvSpPr>
+        <p:spPr>
+          <a:xfrm>
+            <a:off x="1060704" y="4718304"/>
+            <a:ext cx="4754880" cy="1225296"/>
           </a:xfrm>
           <a:prstGeom prst="rect">
             <a:avLst/>
@@ -2244,85 +2424,125 @@
           <a:bodyPr wrap="square" lIns="0" tIns="0" rIns="0" bIns="0" rtlCol="0" anchor="ctr"/>
           <a:lstStyle/>
           <a:p>
-            <a:pPr indent="0" marL="0">
-              <a:buNone/>
-            </a:pPr>
-            <a:r>
-              <a:rPr lang="en-US" sz="1250" dirty="0">
-                <a:solidFill>
-                  <a:srgbClr val="A9BBDD"/>
-                </a:solidFill>
-                <a:latin typeface="Calibri" pitchFamily="34" charset="0"/>
-                <a:ea typeface="Calibri" pitchFamily="34" charset="-122"/>
-                <a:cs typeface="Calibri" pitchFamily="34" charset="-120"/>
-              </a:rPr>
-              <a:t>同機種串著跑，工程師被釋放後全廠少等</a:t>
-            </a:r>
-            <a:endParaRPr lang="en-US" sz="1250" dirty="0"/>
-          </a:p>
-        </p:txBody>
-      </p:sp>
-      <p:sp>
-        <p:nvSpPr>
-          <p:cNvPr id="10" name="Text 8"/>
-          <p:cNvSpPr txBox="1"/>
-          <p:nvPr/>
-        </p:nvSpPr>
-        <p:spPr>
-          <a:xfrm>
-            <a:off x="8321040" y="1728216"/>
-            <a:ext cx="3063240" cy="457200"/>
-          </a:xfrm>
-          <a:prstGeom prst="rect">
-            <a:avLst/>
-          </a:prstGeom>
-          <a:noFill/>
-          <a:ln/>
-        </p:spPr>
-        <p:txBody>
-          <a:bodyPr wrap="square" lIns="0" tIns="0" rIns="0" bIns="0" rtlCol="0" anchor="ctr"/>
-          <a:lstStyle/>
-          <a:p>
-            <a:pPr algn="r" indent="0" marL="0">
-              <a:buNone/>
-            </a:pPr>
-            <a:r>
-              <a:rPr lang="en-US" sz="1900" b="1" dirty="0">
-                <a:solidFill>
-                  <a:srgbClr val="0F7B6C"/>
-                </a:solidFill>
-                <a:latin typeface="Cambria" pitchFamily="34" charset="0"/>
-                <a:ea typeface="Cambria" pitchFamily="34" charset="-122"/>
-                <a:cs typeface="Cambria" pitchFamily="34" charset="-120"/>
-              </a:rPr>
-              <a:t>+41 萬顆／日</a:t>
-            </a:r>
-            <a:endParaRPr lang="en-US" sz="1900" dirty="0"/>
-          </a:p>
-        </p:txBody>
-      </p:sp>
-      <p:sp>
-        <p:nvSpPr>
-          <p:cNvPr id="11" name="Shape 9"/>
+            <a:pPr marL="342900" indent="-342900">
+              <a:lnSpc>
+                <a:spcPts val="1800"/>
+              </a:lnSpc>
+              <a:spcAft>
+                <a:spcPts val="400"/>
+              </a:spcAft>
+              <a:buSzPct val="100000"/>
+              <a:buChar char="•"/>
+            </a:pPr>
+            <a:r>
+              <a:rPr lang="en-US" sz="1200" dirty="0">
+                <a:solidFill>
+                  <a:srgbClr val="16213E"/>
+                </a:solidFill>
+                <a:latin typeface="Calibri" pitchFamily="34" charset="0"/>
+                <a:ea typeface="Calibri" pitchFamily="34" charset="-122"/>
+                <a:cs typeface="Calibri" pitchFamily="34" charset="-120"/>
+              </a:rPr>
+              <a:t>200 批・66.2 萬顆・25 台機（機隊 100 site）</a:t>
+            </a:r>
+            <a:endParaRPr lang="en-US" sz="1200" dirty="0"/>
+          </a:p>
+          <a:p>
+            <a:pPr marL="342900" indent="-342900">
+              <a:lnSpc>
+                <a:spcPts val="1800"/>
+              </a:lnSpc>
+              <a:spcAft>
+                <a:spcPts val="400"/>
+              </a:spcAft>
+              <a:buSzPct val="100000"/>
+              <a:buChar char="•"/>
+            </a:pPr>
+            <a:r>
+              <a:rPr lang="en-US" sz="1200" dirty="0">
+                <a:solidFill>
+                  <a:srgbClr val="16213E"/>
+                </a:solidFill>
+                <a:latin typeface="Calibri" pitchFamily="34" charset="0"/>
+                <a:ea typeface="Calibri" pitchFamily="34" charset="-122"/>
+                <a:cs typeface="Calibri" pitchFamily="34" charset="-120"/>
+              </a:rPr>
+              <a:t>理論最短 4 小時 01 分（零改機零當機）</a:t>
+            </a:r>
+            <a:endParaRPr lang="en-US" sz="1200" dirty="0"/>
+          </a:p>
+          <a:p>
+            <a:pPr marL="342900" indent="-342900">
+              <a:lnSpc>
+                <a:spcPts val="1800"/>
+              </a:lnSpc>
+              <a:spcAft>
+                <a:spcPts val="400"/>
+              </a:spcAft>
+              <a:buSzPct val="100000"/>
+              <a:buChar char="•"/>
+            </a:pPr>
+            <a:r>
+              <a:rPr lang="en-US" sz="1200" dirty="0">
+                <a:solidFill>
+                  <a:srgbClr val="16213E"/>
+                </a:solidFill>
+                <a:latin typeface="Calibri" pitchFamily="34" charset="0"/>
+                <a:ea typeface="Calibri" pitchFamily="34" charset="-122"/>
+                <a:cs typeface="Calibri" pitchFamily="34" charset="-120"/>
+              </a:rPr>
+              <a:t>最快的法則 9 小時 41 分，仍比下限多 142%</a:t>
+            </a:r>
+            <a:endParaRPr lang="en-US" sz="1200" dirty="0"/>
+          </a:p>
+          <a:p>
+            <a:pPr marL="342900" indent="-342900">
+              <a:lnSpc>
+                <a:spcPts val="1800"/>
+              </a:lnSpc>
+              <a:spcAft>
+                <a:spcPts val="400"/>
+              </a:spcAft>
+              <a:buSzPct val="100000"/>
+              <a:buChar char="•"/>
+            </a:pPr>
+            <a:r>
+              <a:rPr lang="en-US" sz="1200" dirty="0">
+                <a:solidFill>
+                  <a:srgbClr val="16213E"/>
+                </a:solidFill>
+                <a:latin typeface="Calibri" pitchFamily="34" charset="0"/>
+                <a:ea typeface="Calibri" pitchFamily="34" charset="-122"/>
+                <a:cs typeface="Calibri" pitchFamily="34" charset="-120"/>
+              </a:rPr>
+              <a:t>最快與最慢差 10 小時 20 分</a:t>
+            </a:r>
+            <a:endParaRPr lang="en-US" sz="1200" dirty="0"/>
+          </a:p>
+        </p:txBody>
+      </p:sp>
+      <p:sp>
+        <p:nvSpPr>
+          <p:cNvPr id="11" name="Shape 7"/>
           <p:cNvSpPr/>
           <p:nvPr/>
         </p:nvSpPr>
         <p:spPr>
           <a:xfrm>
-            <a:off x="566928" y="2587752"/>
-            <a:ext cx="11018520" cy="1051560"/>
+            <a:off x="6172200" y="4206240"/>
+            <a:ext cx="5413248" cy="1828800"/>
           </a:xfrm>
           <a:prstGeom prst="roundRect">
             <a:avLst>
-              <a:gd name="adj" fmla="val 4348"/>
+              <a:gd name="adj" fmla="val 2500"/>
             </a:avLst>
           </a:prstGeom>
           <a:solidFill>
-            <a:srgbClr val="17254C"/>
+            <a:srgbClr val="F5F7FB"/>
           </a:solidFill>
           <a:ln w="12700">
             <a:solidFill>
-              <a:srgbClr val="17254C"/>
+              <a:srgbClr val="FFFFFF"/>
             </a:solidFill>
             <a:prstDash val="solid"/>
           </a:ln>
@@ -2330,24 +2550,24 @@
       </p:sp>
       <p:sp>
         <p:nvSpPr>
-          <p:cNvPr id="12" name="Shape 10"/>
+          <p:cNvPr id="12" name="Shape 8"/>
           <p:cNvSpPr/>
           <p:nvPr/>
         </p:nvSpPr>
         <p:spPr>
           <a:xfrm>
-            <a:off x="841248" y="2898648"/>
-            <a:ext cx="429768" cy="429768"/>
+            <a:off x="6409944" y="4462272"/>
+            <a:ext cx="146304" cy="146304"/>
           </a:xfrm>
           <a:prstGeom prst="ellipse">
             <a:avLst/>
           </a:prstGeom>
           <a:solidFill>
-            <a:srgbClr val="0F7B6C"/>
+            <a:srgbClr val="C2410C"/>
           </a:solidFill>
           <a:ln w="12700">
             <a:solidFill>
-              <a:srgbClr val="0F7B6C"/>
+              <a:srgbClr val="C2410C"/>
             </a:solidFill>
             <a:prstDash val="solid"/>
           </a:ln>
@@ -2355,53 +2575,14 @@
       </p:sp>
       <p:sp>
         <p:nvSpPr>
-          <p:cNvPr id="13" name="Text 11"/>
-          <p:cNvSpPr txBox="1"/>
-          <p:nvPr/>
-        </p:nvSpPr>
-        <p:spPr>
-          <a:xfrm>
-            <a:off x="841248" y="2935224"/>
-            <a:ext cx="429768" cy="365760"/>
-          </a:xfrm>
-          <a:prstGeom prst="rect">
-            <a:avLst/>
-          </a:prstGeom>
-          <a:noFill/>
-          <a:ln/>
-        </p:spPr>
-        <p:txBody>
-          <a:bodyPr wrap="square" lIns="0" tIns="0" rIns="0" bIns="0" rtlCol="0" anchor="ctr"/>
-          <a:lstStyle/>
-          <a:p>
-            <a:pPr algn="ctr" indent="0" marL="0">
-              <a:buNone/>
-            </a:pPr>
-            <a:r>
-              <a:rPr lang="en-US" sz="1600" b="1" dirty="0">
-                <a:solidFill>
-                  <a:srgbClr val="FFFFFF"/>
-                </a:solidFill>
-                <a:latin typeface="Calibri" pitchFamily="34" charset="0"/>
-                <a:ea typeface="Calibri" pitchFamily="34" charset="-122"/>
-                <a:cs typeface="Calibri" pitchFamily="34" charset="-120"/>
-              </a:rPr>
-              <a:t>2</a:t>
-            </a:r>
-            <a:endParaRPr lang="en-US" sz="1600" dirty="0"/>
-          </a:p>
-        </p:txBody>
-      </p:sp>
-      <p:sp>
-        <p:nvSpPr>
-          <p:cNvPr id="14" name="Text 12"/>
-          <p:cNvSpPr txBox="1"/>
-          <p:nvPr/>
-        </p:nvSpPr>
-        <p:spPr>
-          <a:xfrm>
-            <a:off x="1481328" y="2770632"/>
-            <a:ext cx="6583680" cy="365760"/>
+          <p:cNvPr id="13" name="Text 9"/>
+          <p:cNvSpPr txBox="1"/>
+          <p:nvPr/>
+        </p:nvSpPr>
+        <p:spPr>
+          <a:xfrm>
+            <a:off x="6665976" y="4361688"/>
+            <a:ext cx="4681728" cy="329184"/>
           </a:xfrm>
           <a:prstGeom prst="rect">
             <a:avLst/>
@@ -2417,30 +2598,30 @@
               <a:buNone/>
             </a:pPr>
             <a:r>
-              <a:rPr lang="en-US" sz="1700" b="1" dirty="0">
-                <a:solidFill>
-                  <a:srgbClr val="FFFFFF"/>
-                </a:solidFill>
-                <a:latin typeface="Calibri" pitchFamily="34" charset="0"/>
-                <a:ea typeface="Calibri" pitchFamily="34" charset="-122"/>
-                <a:cs typeface="Calibri" pitchFamily="34" charset="-120"/>
-              </a:rPr>
-              <a:t>派工單不提前開，做完當下才決定</a:t>
-            </a:r>
-            <a:endParaRPr lang="en-US" sz="1700" dirty="0"/>
-          </a:p>
-        </p:txBody>
-      </p:sp>
-      <p:sp>
-        <p:nvSpPr>
-          <p:cNvPr id="15" name="Text 13"/>
-          <p:cNvSpPr txBox="1"/>
-          <p:nvPr/>
-        </p:nvSpPr>
-        <p:spPr>
-          <a:xfrm>
-            <a:off x="1481328" y="3154680"/>
-            <a:ext cx="6583680" cy="347472"/>
+              <a:rPr lang="en-US" sz="1450" b="1" dirty="0">
+                <a:solidFill>
+                  <a:srgbClr val="1E2761"/>
+                </a:solidFill>
+                <a:latin typeface="Calibri" pitchFamily="34" charset="0"/>
+                <a:ea typeface="Calibri" pitchFamily="34" charset="-122"/>
+                <a:cs typeface="Calibri" pitchFamily="34" charset="-120"/>
+              </a:rPr>
+              <a:t>完成曲線看得出尾巴</a:t>
+            </a:r>
+            <a:endParaRPr lang="en-US" sz="1450" dirty="0"/>
+          </a:p>
+        </p:txBody>
+      </p:sp>
+      <p:sp>
+        <p:nvSpPr>
+          <p:cNvPr id="14" name="Text 10"/>
+          <p:cNvSpPr txBox="1"/>
+          <p:nvPr/>
+        </p:nvSpPr>
+        <p:spPr>
+          <a:xfrm>
+            <a:off x="6665976" y="4718304"/>
+            <a:ext cx="4681728" cy="1225296"/>
           </a:xfrm>
           <a:prstGeom prst="rect">
             <a:avLst/>
@@ -2450,517 +2631,141 @@
         </p:spPr>
         <p:txBody>
           <a:bodyPr wrap="square" lIns="0" tIns="0" rIns="0" bIns="0" rtlCol="0" anchor="ctr"/>
+          <a:lstStyle/>
+          <a:p>
+            <a:pPr marL="342900" indent="-342900">
+              <a:lnSpc>
+                <a:spcPts val="1800"/>
+              </a:lnSpc>
+              <a:spcAft>
+                <a:spcPts val="400"/>
+              </a:spcAft>
+              <a:buSzPct val="100000"/>
+              <a:buChar char="•"/>
+            </a:pPr>
+            <a:r>
+              <a:rPr lang="en-US" sz="1200" dirty="0">
+                <a:solidFill>
+                  <a:srgbClr val="16213E"/>
+                </a:solidFill>
+                <a:latin typeface="Calibri" pitchFamily="34" charset="0"/>
+                <a:ea typeface="Calibri" pitchFamily="34" charset="-122"/>
+                <a:cs typeface="Calibri" pitchFamily="34" charset="-120"/>
+              </a:rPr>
+              <a:t>省改機前 3 小時就做完 137 批，遙遙領先</a:t>
+            </a:r>
+            <a:endParaRPr lang="en-US" sz="1200" dirty="0"/>
+          </a:p>
+          <a:p>
+            <a:pPr marL="342900" indent="-342900">
+              <a:lnSpc>
+                <a:spcPts val="1800"/>
+              </a:lnSpc>
+              <a:spcAft>
+                <a:spcPts val="400"/>
+              </a:spcAft>
+              <a:buSzPct val="100000"/>
+              <a:buChar char="•"/>
+            </a:pPr>
+            <a:r>
+              <a:rPr lang="en-US" sz="1200" dirty="0">
+                <a:solidFill>
+                  <a:srgbClr val="16213E"/>
+                </a:solidFill>
+                <a:latin typeface="Calibri" pitchFamily="34" charset="0"/>
+                <a:ea typeface="Calibri" pitchFamily="34" charset="-122"/>
+                <a:cs typeface="Calibri" pitchFamily="34" charset="-120"/>
+              </a:rPr>
+              <a:t>但 9 小時後停在 198 批，最後 2 批拖到 14.5 小時</a:t>
+            </a:r>
+            <a:endParaRPr lang="en-US" sz="1200" dirty="0"/>
+          </a:p>
+          <a:p>
+            <a:pPr marL="342900" indent="-342900">
+              <a:lnSpc>
+                <a:spcPts val="1800"/>
+              </a:lnSpc>
+              <a:spcAft>
+                <a:spcPts val="400"/>
+              </a:spcAft>
+              <a:buSzPct val="100000"/>
+              <a:buChar char="•"/>
+            </a:pPr>
+            <a:r>
+              <a:rPr lang="en-US" sz="1200" dirty="0">
+                <a:solidFill>
+                  <a:srgbClr val="16213E"/>
+                </a:solidFill>
+                <a:latin typeface="Calibri" pitchFamily="34" charset="0"/>
+                <a:ea typeface="Calibri" pitchFamily="34" charset="-122"/>
+                <a:cs typeface="Calibri" pitchFamily="34" charset="-120"/>
+              </a:rPr>
+              <a:t>大批給快機起步慢，10 小時整批清光</a:t>
+            </a:r>
+            <a:endParaRPr lang="en-US" sz="1200" dirty="0"/>
+          </a:p>
+          <a:p>
+            <a:pPr marL="342900" indent="-342900">
+              <a:lnSpc>
+                <a:spcPts val="1800"/>
+              </a:lnSpc>
+              <a:spcAft>
+                <a:spcPts val="400"/>
+              </a:spcAft>
+              <a:buSzPct val="100000"/>
+              <a:buChar char="•"/>
+            </a:pPr>
+            <a:r>
+              <a:rPr lang="en-US" sz="1200" dirty="0">
+                <a:solidFill>
+                  <a:srgbClr val="16213E"/>
+                </a:solidFill>
+                <a:latin typeface="Calibri" pitchFamily="34" charset="0"/>
+                <a:ea typeface="Calibri" pitchFamily="34" charset="-122"/>
+                <a:cs typeface="Calibri" pitchFamily="34" charset="-120"/>
+              </a:rPr>
+              <a:t>看整批何時清空，不能只看前段衝得多快</a:t>
+            </a:r>
+            <a:endParaRPr lang="en-US" sz="1200" dirty="0"/>
+          </a:p>
+        </p:txBody>
+      </p:sp>
+      <p:sp>
+        <p:nvSpPr>
+          <p:cNvPr id="15" name="Text 11"/>
+          <p:cNvSpPr txBox="1"/>
+          <p:nvPr/>
+        </p:nvSpPr>
+        <p:spPr>
+          <a:xfrm>
+            <a:off x="566928" y="6126480"/>
+            <a:ext cx="11018520" cy="329184"/>
+          </a:xfrm>
+          <a:prstGeom prst="rect">
+            <a:avLst/>
+          </a:prstGeom>
+          <a:noFill/>
+          <a:ln/>
+        </p:spPr>
+        <p:txBody>
+          <a:bodyPr wrap="square" rtlCol="0" anchor="ctr"/>
           <a:lstStyle/>
           <a:p>
             <a:pPr indent="0" marL="0">
               <a:buNone/>
             </a:pPr>
             <a:r>
-              <a:rPr lang="en-US" sz="1250" dirty="0">
-                <a:solidFill>
-                  <a:srgbClr val="A9BBDD"/>
-                </a:solidFill>
-                <a:latin typeface="Calibri" pitchFamily="34" charset="0"/>
-                <a:ea typeface="Calibri" pitchFamily="34" charset="-122"/>
-                <a:cs typeface="Calibri" pitchFamily="34" charset="-120"/>
-              </a:rPr>
-              <a:t>取消預先押批，改為即時派工</a:t>
-            </a:r>
-            <a:endParaRPr lang="en-US" sz="1250" dirty="0"/>
-          </a:p>
-        </p:txBody>
-      </p:sp>
-      <p:sp>
-        <p:nvSpPr>
-          <p:cNvPr id="16" name="Text 14"/>
-          <p:cNvSpPr txBox="1"/>
-          <p:nvPr/>
-        </p:nvSpPr>
-        <p:spPr>
-          <a:xfrm>
-            <a:off x="8321040" y="2898648"/>
-            <a:ext cx="3063240" cy="457200"/>
-          </a:xfrm>
-          <a:prstGeom prst="rect">
-            <a:avLst/>
-          </a:prstGeom>
-          <a:noFill/>
-          <a:ln/>
-        </p:spPr>
-        <p:txBody>
-          <a:bodyPr wrap="square" lIns="0" tIns="0" rIns="0" bIns="0" rtlCol="0" anchor="ctr"/>
-          <a:lstStyle/>
-          <a:p>
-            <a:pPr algn="r" indent="0" marL="0">
-              <a:buNone/>
-            </a:pPr>
-            <a:r>
-              <a:rPr lang="en-US" sz="1900" b="1" dirty="0">
-                <a:solidFill>
-                  <a:srgbClr val="0F7B6C"/>
-                </a:solidFill>
-                <a:latin typeface="Cambria" pitchFamily="34" charset="0"/>
-                <a:ea typeface="Cambria" pitchFamily="34" charset="-122"/>
-                <a:cs typeface="Cambria" pitchFamily="34" charset="-120"/>
-              </a:rPr>
-              <a:t>+21 萬顆／日</a:t>
-            </a:r>
-            <a:endParaRPr lang="en-US" sz="1900" dirty="0"/>
-          </a:p>
-        </p:txBody>
-      </p:sp>
-      <p:sp>
-        <p:nvSpPr>
-          <p:cNvPr id="17" name="Shape 15"/>
-          <p:cNvSpPr/>
-          <p:nvPr/>
-        </p:nvSpPr>
-        <p:spPr>
-          <a:xfrm>
-            <a:off x="566928" y="3758184"/>
-            <a:ext cx="11018520" cy="1051560"/>
-          </a:xfrm>
-          <a:prstGeom prst="roundRect">
-            <a:avLst>
-              <a:gd name="adj" fmla="val 4348"/>
-            </a:avLst>
-          </a:prstGeom>
-          <a:solidFill>
-            <a:srgbClr val="17254C"/>
-          </a:solidFill>
-          <a:ln w="12700">
-            <a:solidFill>
-              <a:srgbClr val="17254C"/>
-            </a:solidFill>
-            <a:prstDash val="solid"/>
-          </a:ln>
-        </p:spPr>
-      </p:sp>
-      <p:sp>
-        <p:nvSpPr>
-          <p:cNvPr id="18" name="Shape 16"/>
-          <p:cNvSpPr/>
-          <p:nvPr/>
-        </p:nvSpPr>
-        <p:spPr>
-          <a:xfrm>
-            <a:off x="841248" y="4069080"/>
-            <a:ext cx="429768" cy="429768"/>
-          </a:xfrm>
-          <a:prstGeom prst="ellipse">
-            <a:avLst/>
-          </a:prstGeom>
-          <a:solidFill>
-            <a:srgbClr val="1C7293"/>
-          </a:solidFill>
-          <a:ln w="12700">
-            <a:solidFill>
-              <a:srgbClr val="1C7293"/>
-            </a:solidFill>
-            <a:prstDash val="solid"/>
-          </a:ln>
-        </p:spPr>
-      </p:sp>
-      <p:sp>
-        <p:nvSpPr>
-          <p:cNvPr id="19" name="Text 17"/>
-          <p:cNvSpPr txBox="1"/>
-          <p:nvPr/>
-        </p:nvSpPr>
-        <p:spPr>
-          <a:xfrm>
-            <a:off x="841248" y="4105656"/>
-            <a:ext cx="429768" cy="365760"/>
-          </a:xfrm>
-          <a:prstGeom prst="rect">
-            <a:avLst/>
-          </a:prstGeom>
-          <a:noFill/>
-          <a:ln/>
-        </p:spPr>
-        <p:txBody>
-          <a:bodyPr wrap="square" lIns="0" tIns="0" rIns="0" bIns="0" rtlCol="0" anchor="ctr"/>
-          <a:lstStyle/>
-          <a:p>
-            <a:pPr algn="ctr" indent="0" marL="0">
-              <a:buNone/>
-            </a:pPr>
-            <a:r>
-              <a:rPr lang="en-US" sz="1600" b="1" dirty="0">
-                <a:solidFill>
-                  <a:srgbClr val="FFFFFF"/>
-                </a:solidFill>
-                <a:latin typeface="Calibri" pitchFamily="34" charset="0"/>
-                <a:ea typeface="Calibri" pitchFamily="34" charset="-122"/>
-                <a:cs typeface="Calibri" pitchFamily="34" charset="-120"/>
-              </a:rPr>
-              <a:t>3</a:t>
-            </a:r>
-            <a:endParaRPr lang="en-US" sz="1600" dirty="0"/>
-          </a:p>
-        </p:txBody>
-      </p:sp>
-      <p:sp>
-        <p:nvSpPr>
-          <p:cNvPr id="20" name="Text 18"/>
-          <p:cNvSpPr txBox="1"/>
-          <p:nvPr/>
-        </p:nvSpPr>
-        <p:spPr>
-          <a:xfrm>
-            <a:off x="1481328" y="3941064"/>
-            <a:ext cx="6583680" cy="365760"/>
-          </a:xfrm>
-          <a:prstGeom prst="rect">
-            <a:avLst/>
-          </a:prstGeom>
-          <a:noFill/>
-          <a:ln/>
-        </p:spPr>
-        <p:txBody>
-          <a:bodyPr wrap="square" lIns="0" tIns="0" rIns="0" bIns="0" rtlCol="0" anchor="ctr"/>
-          <a:lstStyle/>
-          <a:p>
-            <a:pPr indent="0" marL="0">
-              <a:buNone/>
-            </a:pPr>
-            <a:r>
-              <a:rPr lang="en-US" sz="1700" b="1" dirty="0">
-                <a:solidFill>
-                  <a:srgbClr val="FFFFFF"/>
-                </a:solidFill>
-                <a:latin typeface="Calibri" pitchFamily="34" charset="0"/>
-                <a:ea typeface="Calibri" pitchFamily="34" charset="-122"/>
-                <a:cs typeface="Calibri" pitchFamily="34" charset="-120"/>
-              </a:rPr>
-              <a:t>工程師由 8 人補至 10 人（1:2.5）</a:t>
-            </a:r>
-            <a:endParaRPr lang="en-US" sz="1700" dirty="0"/>
-          </a:p>
-        </p:txBody>
-      </p:sp>
-      <p:sp>
-        <p:nvSpPr>
-          <p:cNvPr id="21" name="Text 19"/>
-          <p:cNvSpPr txBox="1"/>
-          <p:nvPr/>
-        </p:nvSpPr>
-        <p:spPr>
-          <a:xfrm>
-            <a:off x="1481328" y="4325112"/>
-            <a:ext cx="6583680" cy="347472"/>
-          </a:xfrm>
-          <a:prstGeom prst="rect">
-            <a:avLst/>
-          </a:prstGeom>
-          <a:noFill/>
-          <a:ln/>
-        </p:spPr>
-        <p:txBody>
-          <a:bodyPr wrap="square" lIns="0" tIns="0" rIns="0" bIns="0" rtlCol="0" anchor="ctr"/>
-          <a:lstStyle/>
-          <a:p>
-            <a:pPr indent="0" marL="0">
-              <a:buNone/>
-            </a:pPr>
-            <a:r>
-              <a:rPr lang="en-US" sz="1250" dirty="0">
-                <a:solidFill>
-                  <a:srgbClr val="A9BBDD"/>
-                </a:solidFill>
-                <a:latin typeface="Calibri" pitchFamily="34" charset="0"/>
-                <a:ea typeface="Calibri" pitchFamily="34" charset="-122"/>
-                <a:cs typeface="Calibri" pitchFamily="34" charset="-120"/>
-              </a:rPr>
-              <a:t>8 人時有 14.4% 的機台時間在停等</a:t>
-            </a:r>
-            <a:endParaRPr lang="en-US" sz="1250" dirty="0"/>
-          </a:p>
-        </p:txBody>
-      </p:sp>
-      <p:sp>
-        <p:nvSpPr>
-          <p:cNvPr id="22" name="Text 20"/>
-          <p:cNvSpPr txBox="1"/>
-          <p:nvPr/>
-        </p:nvSpPr>
-        <p:spPr>
-          <a:xfrm>
-            <a:off x="8321040" y="4069080"/>
-            <a:ext cx="3063240" cy="457200"/>
-          </a:xfrm>
-          <a:prstGeom prst="rect">
-            <a:avLst/>
-          </a:prstGeom>
-          <a:noFill/>
-          <a:ln/>
-        </p:spPr>
-        <p:txBody>
-          <a:bodyPr wrap="square" lIns="0" tIns="0" rIns="0" bIns="0" rtlCol="0" anchor="ctr"/>
-          <a:lstStyle/>
-          <a:p>
-            <a:pPr algn="r" indent="0" marL="0">
-              <a:buNone/>
-            </a:pPr>
-            <a:r>
-              <a:rPr lang="en-US" sz="1900" b="1" dirty="0">
-                <a:solidFill>
-                  <a:srgbClr val="1C7293"/>
-                </a:solidFill>
-                <a:latin typeface="Cambria" pitchFamily="34" charset="0"/>
-                <a:ea typeface="Cambria" pitchFamily="34" charset="-122"/>
-                <a:cs typeface="Cambria" pitchFamily="34" charset="-120"/>
-              </a:rPr>
-              <a:t>+7 萬顆／日</a:t>
-            </a:r>
-            <a:endParaRPr lang="en-US" sz="1900" dirty="0"/>
-          </a:p>
-        </p:txBody>
-      </p:sp>
-      <p:sp>
-        <p:nvSpPr>
-          <p:cNvPr id="23" name="Shape 21"/>
-          <p:cNvSpPr/>
-          <p:nvPr/>
-        </p:nvSpPr>
-        <p:spPr>
-          <a:xfrm>
-            <a:off x="566928" y="4928616"/>
-            <a:ext cx="11018520" cy="1051560"/>
-          </a:xfrm>
-          <a:prstGeom prst="roundRect">
-            <a:avLst>
-              <a:gd name="adj" fmla="val 4348"/>
-            </a:avLst>
-          </a:prstGeom>
-          <a:solidFill>
-            <a:srgbClr val="17254C"/>
-          </a:solidFill>
-          <a:ln w="12700">
-            <a:solidFill>
-              <a:srgbClr val="17254C"/>
-            </a:solidFill>
-            <a:prstDash val="solid"/>
-          </a:ln>
-        </p:spPr>
-      </p:sp>
-      <p:sp>
-        <p:nvSpPr>
-          <p:cNvPr id="24" name="Shape 22"/>
-          <p:cNvSpPr/>
-          <p:nvPr/>
-        </p:nvSpPr>
-        <p:spPr>
-          <a:xfrm>
-            <a:off x="841248" y="5239512"/>
-            <a:ext cx="429768" cy="429768"/>
-          </a:xfrm>
-          <a:prstGeom prst="ellipse">
-            <a:avLst/>
-          </a:prstGeom>
-          <a:solidFill>
-            <a:srgbClr val="1C7293"/>
-          </a:solidFill>
-          <a:ln w="12700">
-            <a:solidFill>
-              <a:srgbClr val="1C7293"/>
-            </a:solidFill>
-            <a:prstDash val="solid"/>
-          </a:ln>
-        </p:spPr>
-      </p:sp>
-      <p:sp>
-        <p:nvSpPr>
-          <p:cNvPr id="25" name="Text 23"/>
-          <p:cNvSpPr txBox="1"/>
-          <p:nvPr/>
-        </p:nvSpPr>
-        <p:spPr>
-          <a:xfrm>
-            <a:off x="841248" y="5276088"/>
-            <a:ext cx="429768" cy="365760"/>
-          </a:xfrm>
-          <a:prstGeom prst="rect">
-            <a:avLst/>
-          </a:prstGeom>
-          <a:noFill/>
-          <a:ln/>
-        </p:spPr>
-        <p:txBody>
-          <a:bodyPr wrap="square" lIns="0" tIns="0" rIns="0" bIns="0" rtlCol="0" anchor="ctr"/>
-          <a:lstStyle/>
-          <a:p>
-            <a:pPr algn="ctr" indent="0" marL="0">
-              <a:buNone/>
-            </a:pPr>
-            <a:r>
-              <a:rPr lang="en-US" sz="1600" b="1" dirty="0">
-                <a:solidFill>
-                  <a:srgbClr val="FFFFFF"/>
-                </a:solidFill>
-                <a:latin typeface="Calibri" pitchFamily="34" charset="0"/>
-                <a:ea typeface="Calibri" pitchFamily="34" charset="-122"/>
-                <a:cs typeface="Calibri" pitchFamily="34" charset="-120"/>
-              </a:rPr>
-              <a:t>4</a:t>
-            </a:r>
-            <a:endParaRPr lang="en-US" sz="1600" dirty="0"/>
-          </a:p>
-        </p:txBody>
-      </p:sp>
-      <p:sp>
-        <p:nvSpPr>
-          <p:cNvPr id="26" name="Text 24"/>
-          <p:cNvSpPr txBox="1"/>
-          <p:nvPr/>
-        </p:nvSpPr>
-        <p:spPr>
-          <a:xfrm>
-            <a:off x="1481328" y="5111496"/>
-            <a:ext cx="6583680" cy="365760"/>
-          </a:xfrm>
-          <a:prstGeom prst="rect">
-            <a:avLst/>
-          </a:prstGeom>
-          <a:noFill/>
-          <a:ln/>
-        </p:spPr>
-        <p:txBody>
-          <a:bodyPr wrap="square" lIns="0" tIns="0" rIns="0" bIns="0" rtlCol="0" anchor="ctr"/>
-          <a:lstStyle/>
-          <a:p>
-            <a:pPr indent="0" marL="0">
-              <a:buNone/>
-            </a:pPr>
-            <a:r>
-              <a:rPr lang="en-US" sz="1700" b="1" dirty="0">
-                <a:solidFill>
-                  <a:srgbClr val="FFFFFF"/>
-                </a:solidFill>
-                <a:latin typeface="Calibri" pitchFamily="34" charset="0"/>
-                <a:ea typeface="Calibri" pitchFamily="34" charset="-122"/>
-                <a:cs typeface="Calibri" pitchFamily="34" charset="-120"/>
-              </a:rPr>
-              <a:t>縮短換程式時間 30→15 分</a:t>
-            </a:r>
-            <a:endParaRPr lang="en-US" sz="1700" dirty="0"/>
-          </a:p>
-        </p:txBody>
-      </p:sp>
-      <p:sp>
-        <p:nvSpPr>
-          <p:cNvPr id="27" name="Text 25"/>
-          <p:cNvSpPr txBox="1"/>
-          <p:nvPr/>
-        </p:nvSpPr>
-        <p:spPr>
-          <a:xfrm>
-            <a:off x="1481328" y="5495544"/>
-            <a:ext cx="6583680" cy="347472"/>
-          </a:xfrm>
-          <a:prstGeom prst="rect">
-            <a:avLst/>
-          </a:prstGeom>
-          <a:noFill/>
-          <a:ln/>
-        </p:spPr>
-        <p:txBody>
-          <a:bodyPr wrap="square" lIns="0" tIns="0" rIns="0" bIns="0" rtlCol="0" anchor="ctr"/>
-          <a:lstStyle/>
-          <a:p>
-            <a:pPr indent="0" marL="0">
-              <a:buNone/>
-            </a:pPr>
-            <a:r>
-              <a:rPr lang="en-US" sz="1250" dirty="0">
-                <a:solidFill>
-                  <a:srgbClr val="A9BBDD"/>
-                </a:solidFill>
-                <a:latin typeface="Calibri" pitchFamily="34" charset="0"/>
-                <a:ea typeface="Calibri" pitchFamily="34" charset="-122"/>
-                <a:cs typeface="Calibri" pitchFamily="34" charset="-120"/>
-              </a:rPr>
-              <a:t>一天 213 次，槓桿最大的工程改善</a:t>
-            </a:r>
-            <a:endParaRPr lang="en-US" sz="1250" dirty="0"/>
-          </a:p>
-        </p:txBody>
-      </p:sp>
-      <p:sp>
-        <p:nvSpPr>
-          <p:cNvPr id="28" name="Text 26"/>
-          <p:cNvSpPr txBox="1"/>
-          <p:nvPr/>
-        </p:nvSpPr>
-        <p:spPr>
-          <a:xfrm>
-            <a:off x="8321040" y="5239512"/>
-            <a:ext cx="3063240" cy="457200"/>
-          </a:xfrm>
-          <a:prstGeom prst="rect">
-            <a:avLst/>
-          </a:prstGeom>
-          <a:noFill/>
-          <a:ln/>
-        </p:spPr>
-        <p:txBody>
-          <a:bodyPr wrap="square" lIns="0" tIns="0" rIns="0" bIns="0" rtlCol="0" anchor="ctr"/>
-          <a:lstStyle/>
-          <a:p>
-            <a:pPr algn="r" indent="0" marL="0">
-              <a:buNone/>
-            </a:pPr>
-            <a:r>
-              <a:rPr lang="en-US" sz="1900" b="1" dirty="0">
-                <a:solidFill>
-                  <a:srgbClr val="1C7293"/>
-                </a:solidFill>
-                <a:latin typeface="Cambria" pitchFamily="34" charset="0"/>
-                <a:ea typeface="Cambria" pitchFamily="34" charset="-122"/>
-                <a:cs typeface="Cambria" pitchFamily="34" charset="-120"/>
-              </a:rPr>
-              <a:t>+3 萬顆／日</a:t>
-            </a:r>
-            <a:endParaRPr lang="en-US" sz="1900" dirty="0"/>
-          </a:p>
-        </p:txBody>
-      </p:sp>
-      <p:sp>
-        <p:nvSpPr>
-          <p:cNvPr id="29" name="Text 27"/>
-          <p:cNvSpPr txBox="1"/>
-          <p:nvPr/>
-        </p:nvSpPr>
-        <p:spPr>
-          <a:xfrm>
-            <a:off x="566928" y="6108192"/>
-            <a:ext cx="11018520" cy="384048"/>
-          </a:xfrm>
-          <a:prstGeom prst="rect">
-            <a:avLst/>
-          </a:prstGeom>
-          <a:noFill/>
-          <a:ln/>
-        </p:spPr>
-        <p:txBody>
-          <a:bodyPr wrap="square" rtlCol="0" anchor="ctr"/>
-          <a:lstStyle/>
-          <a:p>
-            <a:pPr algn="ctr" indent="0" marL="0">
-              <a:buNone/>
-            </a:pPr>
-            <a:r>
-              <a:rPr lang="en-US" sz="1300" dirty="0">
-                <a:solidFill>
-                  <a:srgbClr val="CADCFC"/>
-                </a:solidFill>
-                <a:latin typeface="Calibri" pitchFamily="34" charset="0"/>
-                <a:ea typeface="Calibri" pitchFamily="34" charset="-122"/>
-                <a:cs typeface="Calibri" pitchFamily="34" charset="-120"/>
-              </a:rPr>
-              <a:t>四項全做：每日良品 77 萬 → 148 萬顆（+93%），逾期批數 220 批 → 2 批以下</a:t>
-            </a:r>
-            <a:endParaRPr lang="en-US" sz="1300" dirty="0"/>
+              <a:rPr lang="en-US" sz="1100" dirty="0">
+                <a:solidFill>
+                  <a:srgbClr val="5A6785"/>
+                </a:solidFill>
+                <a:latin typeface="Calibri" pitchFamily="34" charset="0"/>
+                <a:ea typeface="Calibri" pitchFamily="34" charset="-122"/>
+                <a:cs typeface="Calibri" pitchFamily="34" charset="-120"/>
+              </a:rPr>
+              <a:t>註　情境為「純排程比較」：關閉當機與良率波動，同一批貨每次跑結果完全相同，法則之間的差異純粹來自排程順序。</a:t>
+            </a:r>
+            <a:endParaRPr lang="en-US" sz="1100" dirty="0"/>
           </a:p>
         </p:txBody>
       </p:sp>
@@ -3061,7 +2866,7 @@
                 <a:ea typeface="Cambria" pitchFamily="34" charset="-122"/>
                 <a:cs typeface="Cambria" pitchFamily="34" charset="-120"/>
               </a:rPr>
-              <a:t>實施路徑、追蹤指標與模型限制</a:t>
+              <a:t>人力改變了最佳排程法則</a:t>
             </a:r>
             <a:endParaRPr lang="en-US" sz="3000" dirty="0"/>
           </a:p>
@@ -3100,26 +2905,74 @@
                 <a:ea typeface="Calibri" pitchFamily="34" charset="-122"/>
                 <a:cs typeface="Calibri" pitchFamily="34" charset="-120"/>
               </a:rPr>
-              <a:t>建議以四週為一個驗證循環，每一步都有可量測的指標</a:t>
+              <a:t>同一批貨、同一組機台，只改工程師人數，冠軍法則就換人做——這是前面所有結論的邊界條件</a:t>
             </a:r>
             <a:endParaRPr lang="en-US" sz="1350" dirty="0"/>
           </a:p>
         </p:txBody>
       </p:sp>
-      <p:sp>
-        <p:nvSpPr>
-          <p:cNvPr id="5" name="Shape 3"/>
+      <p:pic>
+        <p:nvPicPr>
+          <p:cNvPr id="5" name="Image 0" descr="charts/c_engpol.png">    </p:cNvPr>
+          <p:cNvPicPr>
+            <a:picLocks noChangeAspect="1"/>
+          </p:cNvPicPr>
+          <p:nvPr/>
+        </p:nvPicPr>
+        <p:blipFill>
+          <a:blip r:embed="rId1"/>
+          <a:stretch>
+            <a:fillRect/>
+          </a:stretch>
+        </p:blipFill>
+        <p:spPr>
+          <a:xfrm>
+            <a:off x="566928" y="1335024"/>
+            <a:ext cx="5394960" cy="3591134"/>
+          </a:xfrm>
+          <a:prstGeom prst="rect">
+            <a:avLst/>
+          </a:prstGeom>
+        </p:spPr>
+      </p:pic>
+      <p:pic>
+        <p:nvPicPr>
+          <p:cNvPr id="6" name="Image 1" descr="charts/c_frozen.png">    </p:cNvPr>
+          <p:cNvPicPr>
+            <a:picLocks noChangeAspect="1"/>
+          </p:cNvPicPr>
+          <p:nvPr/>
+        </p:nvPicPr>
+        <p:blipFill>
+          <a:blip r:embed="rId2"/>
+          <a:stretch>
+            <a:fillRect/>
+          </a:stretch>
+        </p:blipFill>
+        <p:spPr>
+          <a:xfrm>
+            <a:off x="6592824" y="1335024"/>
+            <a:ext cx="5029200" cy="3601289"/>
+          </a:xfrm>
+          <a:prstGeom prst="rect">
+            <a:avLst/>
+          </a:prstGeom>
+        </p:spPr>
+      </p:pic>
+      <p:sp>
+        <p:nvSpPr>
+          <p:cNvPr id="7" name="Shape 3"/>
           <p:cNvSpPr/>
           <p:nvPr/>
         </p:nvSpPr>
         <p:spPr>
           <a:xfrm>
-            <a:off x="566928" y="1417320"/>
-            <a:ext cx="2670048" cy="2560320"/>
+            <a:off x="566928" y="5047488"/>
+            <a:ext cx="5486400" cy="1600200"/>
           </a:xfrm>
           <a:prstGeom prst="roundRect">
             <a:avLst>
-              <a:gd name="adj" fmla="val 1786"/>
+              <a:gd name="adj" fmla="val 2857"/>
             </a:avLst>
           </a:prstGeom>
           <a:solidFill>
@@ -3135,6 +2988,1577 @@
       </p:sp>
       <p:sp>
         <p:nvSpPr>
+          <p:cNvPr id="8" name="Shape 4"/>
+          <p:cNvSpPr/>
+          <p:nvPr/>
+        </p:nvSpPr>
+        <p:spPr>
+          <a:xfrm>
+            <a:off x="804672" y="5303520"/>
+            <a:ext cx="146304" cy="146304"/>
+          </a:xfrm>
+          <a:prstGeom prst="ellipse">
+            <a:avLst/>
+          </a:prstGeom>
+          <a:solidFill>
+            <a:srgbClr val="0F7B6C"/>
+          </a:solidFill>
+          <a:ln w="12700">
+            <a:solidFill>
+              <a:srgbClr val="0F7B6C"/>
+            </a:solidFill>
+            <a:prstDash val="solid"/>
+          </a:ln>
+        </p:spPr>
+      </p:sp>
+      <p:sp>
+        <p:nvSpPr>
+          <p:cNvPr id="9" name="Text 5"/>
+          <p:cNvSpPr txBox="1"/>
+          <p:nvPr/>
+        </p:nvSpPr>
+        <p:spPr>
+          <a:xfrm>
+            <a:off x="1060704" y="5202936"/>
+            <a:ext cx="4754880" cy="329184"/>
+          </a:xfrm>
+          <a:prstGeom prst="rect">
+            <a:avLst/>
+          </a:prstGeom>
+          <a:noFill/>
+          <a:ln/>
+        </p:spPr>
+        <p:txBody>
+          <a:bodyPr wrap="square" lIns="0" tIns="0" rIns="0" bIns="0" rtlCol="0" anchor="ctr"/>
+          <a:lstStyle/>
+          <a:p>
+            <a:pPr indent="0" marL="0">
+              <a:buNone/>
+            </a:pPr>
+            <a:r>
+              <a:rPr lang="en-US" sz="1450" b="1" dirty="0">
+                <a:solidFill>
+                  <a:srgbClr val="1E2761"/>
+                </a:solidFill>
+                <a:latin typeface="Calibri" pitchFamily="34" charset="0"/>
+                <a:ea typeface="Calibri" pitchFamily="34" charset="-122"/>
+                <a:cs typeface="Calibri" pitchFamily="34" charset="-120"/>
+              </a:rPr>
+              <a:t>交叉點在 5～10 人之間</a:t>
+            </a:r>
+            <a:endParaRPr lang="en-US" sz="1450" dirty="0"/>
+          </a:p>
+        </p:txBody>
+      </p:sp>
+      <p:sp>
+        <p:nvSpPr>
+          <p:cNvPr id="10" name="Text 6"/>
+          <p:cNvSpPr txBox="1"/>
+          <p:nvPr/>
+        </p:nvSpPr>
+        <p:spPr>
+          <a:xfrm>
+            <a:off x="1060704" y="5559552"/>
+            <a:ext cx="4754880" cy="996696"/>
+          </a:xfrm>
+          <a:prstGeom prst="rect">
+            <a:avLst/>
+          </a:prstGeom>
+          <a:noFill/>
+          <a:ln/>
+        </p:spPr>
+        <p:txBody>
+          <a:bodyPr wrap="square" lIns="0" tIns="0" rIns="0" bIns="0" rtlCol="0" anchor="ctr"/>
+          <a:lstStyle/>
+          <a:p>
+            <a:pPr marL="342900" indent="-342900">
+              <a:lnSpc>
+                <a:spcPts val="1800"/>
+              </a:lnSpc>
+              <a:spcAft>
+                <a:spcPts val="400"/>
+              </a:spcAft>
+              <a:buSzPct val="100000"/>
+              <a:buChar char="•"/>
+            </a:pPr>
+            <a:r>
+              <a:rPr lang="en-US" sz="1200" dirty="0">
+                <a:solidFill>
+                  <a:srgbClr val="16213E"/>
+                </a:solidFill>
+                <a:latin typeface="Calibri" pitchFamily="34" charset="0"/>
+                <a:ea typeface="Calibri" pitchFamily="34" charset="-122"/>
+                <a:cs typeface="Calibri" pitchFamily="34" charset="-120"/>
+              </a:rPr>
+              <a:t>3 人：省改機 13.5 h 勝出，大批給快機要 18.0 h</a:t>
+            </a:r>
+            <a:endParaRPr lang="en-US" sz="1200" dirty="0"/>
+          </a:p>
+          <a:p>
+            <a:pPr marL="342900" indent="-342900">
+              <a:lnSpc>
+                <a:spcPts val="1800"/>
+              </a:lnSpc>
+              <a:spcAft>
+                <a:spcPts val="400"/>
+              </a:spcAft>
+              <a:buSzPct val="100000"/>
+              <a:buChar char="•"/>
+            </a:pPr>
+            <a:r>
+              <a:rPr lang="en-US" sz="1200" dirty="0">
+                <a:solidFill>
+                  <a:srgbClr val="16213E"/>
+                </a:solidFill>
+                <a:latin typeface="Calibri" pitchFamily="34" charset="0"/>
+                <a:ea typeface="Calibri" pitchFamily="34" charset="-122"/>
+                <a:cs typeface="Calibri" pitchFamily="34" charset="-120"/>
+              </a:rPr>
+              <a:t>10 人：大批給快機 9.7 h，省改機落到 14.5 h</a:t>
+            </a:r>
+            <a:endParaRPr lang="en-US" sz="1200" dirty="0"/>
+          </a:p>
+          <a:p>
+            <a:pPr marL="342900" indent="-342900">
+              <a:lnSpc>
+                <a:spcPts val="1800"/>
+              </a:lnSpc>
+              <a:spcAft>
+                <a:spcPts val="400"/>
+              </a:spcAft>
+              <a:buSzPct val="100000"/>
+              <a:buChar char="•"/>
+            </a:pPr>
+            <a:r>
+              <a:rPr lang="en-US" sz="1200" dirty="0">
+                <a:solidFill>
+                  <a:srgbClr val="16213E"/>
+                </a:solidFill>
+                <a:latin typeface="Calibri" pitchFamily="34" charset="0"/>
+                <a:ea typeface="Calibri" pitchFamily="34" charset="-122"/>
+                <a:cs typeface="Calibri" pitchFamily="34" charset="-120"/>
+              </a:rPr>
+              <a:t>人少 → 改機排隊；人多 → 閒機排隊</a:t>
+            </a:r>
+            <a:endParaRPr lang="en-US" sz="1200" dirty="0"/>
+          </a:p>
+        </p:txBody>
+      </p:sp>
+      <p:sp>
+        <p:nvSpPr>
+          <p:cNvPr id="11" name="Shape 7"/>
+          <p:cNvSpPr/>
+          <p:nvPr/>
+        </p:nvSpPr>
+        <p:spPr>
+          <a:xfrm>
+            <a:off x="6172200" y="5047488"/>
+            <a:ext cx="5413248" cy="1600200"/>
+          </a:xfrm>
+          <a:prstGeom prst="roundRect">
+            <a:avLst>
+              <a:gd name="adj" fmla="val 2857"/>
+            </a:avLst>
+          </a:prstGeom>
+          <a:solidFill>
+            <a:srgbClr val="F5F7FB"/>
+          </a:solidFill>
+          <a:ln w="12700">
+            <a:solidFill>
+              <a:srgbClr val="FFFFFF"/>
+            </a:solidFill>
+            <a:prstDash val="solid"/>
+          </a:ln>
+        </p:spPr>
+      </p:sp>
+      <p:sp>
+        <p:nvSpPr>
+          <p:cNvPr id="12" name="Shape 8"/>
+          <p:cNvSpPr/>
+          <p:nvPr/>
+        </p:nvSpPr>
+        <p:spPr>
+          <a:xfrm>
+            <a:off x="6409944" y="5303520"/>
+            <a:ext cx="146304" cy="146304"/>
+          </a:xfrm>
+          <a:prstGeom prst="ellipse">
+            <a:avLst/>
+          </a:prstGeom>
+          <a:solidFill>
+            <a:srgbClr val="C2410C"/>
+          </a:solidFill>
+          <a:ln w="12700">
+            <a:solidFill>
+              <a:srgbClr val="C2410C"/>
+            </a:solidFill>
+            <a:prstDash val="solid"/>
+          </a:ln>
+        </p:spPr>
+      </p:sp>
+      <p:sp>
+        <p:nvSpPr>
+          <p:cNvPr id="13" name="Text 9"/>
+          <p:cNvSpPr txBox="1"/>
+          <p:nvPr/>
+        </p:nvSpPr>
+        <p:spPr>
+          <a:xfrm>
+            <a:off x="6665976" y="5202936"/>
+            <a:ext cx="4681728" cy="329184"/>
+          </a:xfrm>
+          <a:prstGeom prst="rect">
+            <a:avLst/>
+          </a:prstGeom>
+          <a:noFill/>
+          <a:ln/>
+        </p:spPr>
+        <p:txBody>
+          <a:bodyPr wrap="square" lIns="0" tIns="0" rIns="0" bIns="0" rtlCol="0" anchor="ctr"/>
+          <a:lstStyle/>
+          <a:p>
+            <a:pPr indent="0" marL="0">
+              <a:buNone/>
+            </a:pPr>
+            <a:r>
+              <a:rPr lang="en-US" sz="1450" b="1" dirty="0">
+                <a:solidFill>
+                  <a:srgbClr val="1E2761"/>
+                </a:solidFill>
+                <a:latin typeface="Calibri" pitchFamily="34" charset="0"/>
+                <a:ea typeface="Calibri" pitchFamily="34" charset="-122"/>
+                <a:cs typeface="Calibri" pitchFamily="34" charset="-120"/>
+              </a:rPr>
+              <a:t>為什麼省改機在人多時會輸</a:t>
+            </a:r>
+            <a:endParaRPr lang="en-US" sz="1450" dirty="0"/>
+          </a:p>
+        </p:txBody>
+      </p:sp>
+      <p:sp>
+        <p:nvSpPr>
+          <p:cNvPr id="14" name="Text 10"/>
+          <p:cNvSpPr txBox="1"/>
+          <p:nvPr/>
+        </p:nvSpPr>
+        <p:spPr>
+          <a:xfrm>
+            <a:off x="6665976" y="5559552"/>
+            <a:ext cx="4681728" cy="996696"/>
+          </a:xfrm>
+          <a:prstGeom prst="rect">
+            <a:avLst/>
+          </a:prstGeom>
+          <a:noFill/>
+          <a:ln/>
+        </p:spPr>
+        <p:txBody>
+          <a:bodyPr wrap="square" lIns="0" tIns="0" rIns="0" bIns="0" rtlCol="0" anchor="ctr"/>
+          <a:lstStyle/>
+          <a:p>
+            <a:pPr marL="342900" indent="-342900">
+              <a:lnSpc>
+                <a:spcPts val="1800"/>
+              </a:lnSpc>
+              <a:spcAft>
+                <a:spcPts val="400"/>
+              </a:spcAft>
+              <a:buSzPct val="100000"/>
+              <a:buChar char="•"/>
+            </a:pPr>
+            <a:r>
+              <a:rPr lang="en-US" sz="1200" dirty="0">
+                <a:solidFill>
+                  <a:srgbClr val="16213E"/>
+                </a:solidFill>
+                <a:latin typeface="Calibri" pitchFamily="34" charset="0"/>
+                <a:ea typeface="Calibri" pitchFamily="34" charset="-122"/>
+                <a:cs typeface="Calibri" pitchFamily="34" charset="-120"/>
+              </a:rPr>
+              <a:t>不換 Kit ＝ 把機台配置凍結在現況</a:t>
+            </a:r>
+            <a:endParaRPr lang="en-US" sz="1200" dirty="0"/>
+          </a:p>
+          <a:p>
+            <a:pPr marL="342900" indent="-342900">
+              <a:lnSpc>
+                <a:spcPts val="1800"/>
+              </a:lnSpc>
+              <a:spcAft>
+                <a:spcPts val="400"/>
+              </a:spcAft>
+              <a:buSzPct val="100000"/>
+              <a:buChar char="•"/>
+            </a:pPr>
+            <a:r>
+              <a:rPr lang="en-US" sz="1200" dirty="0">
+                <a:solidFill>
+                  <a:srgbClr val="16213E"/>
+                </a:solidFill>
+                <a:latin typeface="Calibri" pitchFamily="34" charset="0"/>
+                <a:ea typeface="Calibri" pitchFamily="34" charset="-122"/>
+                <a:cs typeface="Calibri" pitchFamily="34" charset="-120"/>
+              </a:rPr>
+              <a:t>QFN32 佔 38.6% 工時，卻只有 22/100 site 裝著它</a:t>
+            </a:r>
+            <a:endParaRPr lang="en-US" sz="1200" dirty="0"/>
+          </a:p>
+          <a:p>
+            <a:pPr marL="342900" indent="-342900">
+              <a:lnSpc>
+                <a:spcPts val="1800"/>
+              </a:lnSpc>
+              <a:spcAft>
+                <a:spcPts val="400"/>
+              </a:spcAft>
+              <a:buSzPct val="100000"/>
+              <a:buChar char="•"/>
+            </a:pPr>
+            <a:r>
+              <a:rPr lang="en-US" sz="1200" dirty="0">
+                <a:solidFill>
+                  <a:srgbClr val="16213E"/>
+                </a:solidFill>
+                <a:latin typeface="Calibri" pitchFamily="34" charset="0"/>
+                <a:ea typeface="Calibri" pitchFamily="34" charset="-122"/>
+                <a:cs typeface="Calibri" pitchFamily="34" charset="-120"/>
+              </a:rPr>
+              <a:t>光這一種封裝就要 7 小時，其他機台只能閒著</a:t>
+            </a:r>
+            <a:endParaRPr lang="en-US" sz="1200" dirty="0"/>
+          </a:p>
+        </p:txBody>
+      </p:sp>
+    </p:spTree>
+  </p:cSld>
+  <p:clrMapOvr>
+    <a:masterClrMapping/>
+  </p:clrMapOvr>
+</p:sld>
+</file>
+
+<file path=ppt/slides/slide12.xml><?xml version="1.0" encoding="utf-8"?>
+<p:sld xmlns:a="http://schemas.openxmlformats.org/drawingml/2006/main" xmlns:r="http://schemas.openxmlformats.org/officeDocument/2006/relationships" xmlns:p="http://schemas.openxmlformats.org/presentationml/2006/main">
+  <p:cSld name="Slide 12">
+    <p:bg>
+      <p:bgPr>
+        <a:solidFill>
+          <a:srgbClr val="0E1A3C"/>
+        </a:solidFill>
+      </p:bgPr>
+    </p:bg>
+    <p:spTree>
+      <p:nvGrpSpPr>
+        <p:cNvPr id="1" name=""/>
+        <p:cNvGrpSpPr/>
+        <p:nvPr/>
+      </p:nvGrpSpPr>
+      <p:grpSpPr>
+        <a:xfrm>
+          <a:off x="0" y="0"/>
+          <a:ext cx="0" cy="0"/>
+          <a:chOff x="0" y="0"/>
+          <a:chExt cx="0" cy="0"/>
+        </a:xfrm>
+      </p:grpSpPr>
+      <p:sp>
+        <p:nvSpPr>
+          <p:cNvPr id="2" name="Text 0"/>
+          <p:cNvSpPr txBox="1"/>
+          <p:nvPr/>
+        </p:nvSpPr>
+        <p:spPr>
+          <a:xfrm>
+            <a:off x="566928" y="384048"/>
+            <a:ext cx="502920" cy="457200"/>
+          </a:xfrm>
+          <a:prstGeom prst="rect">
+            <a:avLst/>
+          </a:prstGeom>
+          <a:noFill/>
+          <a:ln/>
+        </p:spPr>
+        <p:txBody>
+          <a:bodyPr wrap="square" rtlCol="0" anchor="ctr"/>
+          <a:lstStyle/>
+          <a:p>
+            <a:pPr indent="0" marL="0">
+              <a:buNone/>
+            </a:pPr>
+            <a:r>
+              <a:rPr lang="en-US" sz="1300" b="1" dirty="0">
+                <a:solidFill>
+                  <a:srgbClr val="1C7293"/>
+                </a:solidFill>
+                <a:latin typeface="Calibri" pitchFamily="34" charset="0"/>
+                <a:ea typeface="Calibri" pitchFamily="34" charset="-122"/>
+                <a:cs typeface="Calibri" pitchFamily="34" charset="-120"/>
+              </a:rPr>
+              <a:t>11</a:t>
+            </a:r>
+            <a:endParaRPr lang="en-US" sz="1300" dirty="0"/>
+          </a:p>
+        </p:txBody>
+      </p:sp>
+      <p:sp>
+        <p:nvSpPr>
+          <p:cNvPr id="3" name="Text 1"/>
+          <p:cNvSpPr txBox="1"/>
+          <p:nvPr/>
+        </p:nvSpPr>
+        <p:spPr>
+          <a:xfrm>
+            <a:off x="1143000" y="310896"/>
+            <a:ext cx="10424160" cy="566928"/>
+          </a:xfrm>
+          <a:prstGeom prst="rect">
+            <a:avLst/>
+          </a:prstGeom>
+          <a:noFill/>
+          <a:ln/>
+        </p:spPr>
+        <p:txBody>
+          <a:bodyPr wrap="square" rtlCol="0" anchor="ctr"/>
+          <a:lstStyle/>
+          <a:p>
+            <a:pPr indent="0" marL="0">
+              <a:buNone/>
+            </a:pPr>
+            <a:r>
+              <a:rPr lang="en-US" sz="3000" b="1" dirty="0">
+                <a:solidFill>
+                  <a:srgbClr val="FFFFFF"/>
+                </a:solidFill>
+                <a:latin typeface="Cambria" pitchFamily="34" charset="0"/>
+                <a:ea typeface="Cambria" pitchFamily="34" charset="-122"/>
+                <a:cs typeface="Cambria" pitchFamily="34" charset="-120"/>
+              </a:rPr>
+              <a:t>專業建議</a:t>
+            </a:r>
+            <a:endParaRPr lang="en-US" sz="3000" dirty="0"/>
+          </a:p>
+        </p:txBody>
+      </p:sp>
+      <p:sp>
+        <p:nvSpPr>
+          <p:cNvPr id="4" name="Text 2"/>
+          <p:cNvSpPr txBox="1"/>
+          <p:nvPr/>
+        </p:nvSpPr>
+        <p:spPr>
+          <a:xfrm>
+            <a:off x="1143000" y="896112"/>
+            <a:ext cx="10424160" cy="365760"/>
+          </a:xfrm>
+          <a:prstGeom prst="rect">
+            <a:avLst/>
+          </a:prstGeom>
+          <a:noFill/>
+          <a:ln/>
+        </p:spPr>
+        <p:txBody>
+          <a:bodyPr wrap="square" rtlCol="0" anchor="ctr"/>
+          <a:lstStyle/>
+          <a:p>
+            <a:pPr indent="0" marL="0">
+              <a:buNone/>
+            </a:pPr>
+            <a:r>
+              <a:rPr lang="en-US" sz="1350" dirty="0">
+                <a:solidFill>
+                  <a:srgbClr val="CADCFC"/>
+                </a:solidFill>
+                <a:latin typeface="Calibri" pitchFamily="34" charset="0"/>
+                <a:ea typeface="Calibri" pitchFamily="34" charset="-122"/>
+                <a:cs typeface="Calibri" pitchFamily="34" charset="-120"/>
+              </a:rPr>
+              <a:t>依「投入成本 → 效益」排序，前兩項不需任何資本支出</a:t>
+            </a:r>
+            <a:endParaRPr lang="en-US" sz="1350" dirty="0"/>
+          </a:p>
+        </p:txBody>
+      </p:sp>
+      <p:sp>
+        <p:nvSpPr>
+          <p:cNvPr id="5" name="Shape 3"/>
+          <p:cNvSpPr/>
+          <p:nvPr/>
+        </p:nvSpPr>
+        <p:spPr>
+          <a:xfrm>
+            <a:off x="566928" y="1417320"/>
+            <a:ext cx="11018520" cy="1051560"/>
+          </a:xfrm>
+          <a:prstGeom prst="roundRect">
+            <a:avLst>
+              <a:gd name="adj" fmla="val 4348"/>
+            </a:avLst>
+          </a:prstGeom>
+          <a:solidFill>
+            <a:srgbClr val="17254C"/>
+          </a:solidFill>
+          <a:ln w="12700">
+            <a:solidFill>
+              <a:srgbClr val="17254C"/>
+            </a:solidFill>
+            <a:prstDash val="solid"/>
+          </a:ln>
+        </p:spPr>
+      </p:sp>
+      <p:sp>
+        <p:nvSpPr>
+          <p:cNvPr id="6" name="Shape 4"/>
+          <p:cNvSpPr/>
+          <p:nvPr/>
+        </p:nvSpPr>
+        <p:spPr>
+          <a:xfrm>
+            <a:off x="841248" y="1728216"/>
+            <a:ext cx="429768" cy="429768"/>
+          </a:xfrm>
+          <a:prstGeom prst="ellipse">
+            <a:avLst/>
+          </a:prstGeom>
+          <a:solidFill>
+            <a:srgbClr val="0F7B6C"/>
+          </a:solidFill>
+          <a:ln w="12700">
+            <a:solidFill>
+              <a:srgbClr val="0F7B6C"/>
+            </a:solidFill>
+            <a:prstDash val="solid"/>
+          </a:ln>
+        </p:spPr>
+      </p:sp>
+      <p:sp>
+        <p:nvSpPr>
+          <p:cNvPr id="7" name="Text 5"/>
+          <p:cNvSpPr txBox="1"/>
+          <p:nvPr/>
+        </p:nvSpPr>
+        <p:spPr>
+          <a:xfrm>
+            <a:off x="841248" y="1764792"/>
+            <a:ext cx="429768" cy="365760"/>
+          </a:xfrm>
+          <a:prstGeom prst="rect">
+            <a:avLst/>
+          </a:prstGeom>
+          <a:noFill/>
+          <a:ln/>
+        </p:spPr>
+        <p:txBody>
+          <a:bodyPr wrap="square" lIns="0" tIns="0" rIns="0" bIns="0" rtlCol="0" anchor="ctr"/>
+          <a:lstStyle/>
+          <a:p>
+            <a:pPr algn="ctr" indent="0" marL="0">
+              <a:buNone/>
+            </a:pPr>
+            <a:r>
+              <a:rPr lang="en-US" sz="1600" b="1" dirty="0">
+                <a:solidFill>
+                  <a:srgbClr val="FFFFFF"/>
+                </a:solidFill>
+                <a:latin typeface="Calibri" pitchFamily="34" charset="0"/>
+                <a:ea typeface="Calibri" pitchFamily="34" charset="-122"/>
+                <a:cs typeface="Calibri" pitchFamily="34" charset="-120"/>
+              </a:rPr>
+              <a:t>1</a:t>
+            </a:r>
+            <a:endParaRPr lang="en-US" sz="1600" dirty="0"/>
+          </a:p>
+        </p:txBody>
+      </p:sp>
+      <p:sp>
+        <p:nvSpPr>
+          <p:cNvPr id="8" name="Text 6"/>
+          <p:cNvSpPr txBox="1"/>
+          <p:nvPr/>
+        </p:nvSpPr>
+        <p:spPr>
+          <a:xfrm>
+            <a:off x="1481328" y="1600200"/>
+            <a:ext cx="6583680" cy="365760"/>
+          </a:xfrm>
+          <a:prstGeom prst="rect">
+            <a:avLst/>
+          </a:prstGeom>
+          <a:noFill/>
+          <a:ln/>
+        </p:spPr>
+        <p:txBody>
+          <a:bodyPr wrap="square" lIns="0" tIns="0" rIns="0" bIns="0" rtlCol="0" anchor="ctr"/>
+          <a:lstStyle/>
+          <a:p>
+            <a:pPr indent="0" marL="0">
+              <a:buNone/>
+            </a:pPr>
+            <a:r>
+              <a:rPr lang="en-US" sz="1700" b="1" dirty="0">
+                <a:solidFill>
+                  <a:srgbClr val="FFFFFF"/>
+                </a:solidFill>
+                <a:latin typeface="Calibri" pitchFamily="34" charset="0"/>
+                <a:ea typeface="Calibri" pitchFamily="34" charset="-122"/>
+                <a:cs typeface="Calibri" pitchFamily="34" charset="-120"/>
+              </a:rPr>
+              <a:t>排程法則改為「省改機優先」</a:t>
+            </a:r>
+            <a:endParaRPr lang="en-US" sz="1700" dirty="0"/>
+          </a:p>
+        </p:txBody>
+      </p:sp>
+      <p:sp>
+        <p:nvSpPr>
+          <p:cNvPr id="9" name="Text 7"/>
+          <p:cNvSpPr txBox="1"/>
+          <p:nvPr/>
+        </p:nvSpPr>
+        <p:spPr>
+          <a:xfrm>
+            <a:off x="1481328" y="1984248"/>
+            <a:ext cx="6583680" cy="347472"/>
+          </a:xfrm>
+          <a:prstGeom prst="rect">
+            <a:avLst/>
+          </a:prstGeom>
+          <a:noFill/>
+          <a:ln/>
+        </p:spPr>
+        <p:txBody>
+          <a:bodyPr wrap="square" lIns="0" tIns="0" rIns="0" bIns="0" rtlCol="0" anchor="ctr"/>
+          <a:lstStyle/>
+          <a:p>
+            <a:pPr indent="0" marL="0">
+              <a:buNone/>
+            </a:pPr>
+            <a:r>
+              <a:rPr lang="en-US" sz="1250" dirty="0">
+                <a:solidFill>
+                  <a:srgbClr val="A9BBDD"/>
+                </a:solidFill>
+                <a:latin typeface="Calibri" pitchFamily="34" charset="0"/>
+                <a:ea typeface="Calibri" pitchFamily="34" charset="-122"/>
+                <a:cs typeface="Calibri" pitchFamily="34" charset="-120"/>
+              </a:rPr>
+              <a:t>同機種串著跑，工程師被釋放後全廠少等</a:t>
+            </a:r>
+            <a:endParaRPr lang="en-US" sz="1250" dirty="0"/>
+          </a:p>
+        </p:txBody>
+      </p:sp>
+      <p:sp>
+        <p:nvSpPr>
+          <p:cNvPr id="10" name="Text 8"/>
+          <p:cNvSpPr txBox="1"/>
+          <p:nvPr/>
+        </p:nvSpPr>
+        <p:spPr>
+          <a:xfrm>
+            <a:off x="8321040" y="1728216"/>
+            <a:ext cx="3063240" cy="457200"/>
+          </a:xfrm>
+          <a:prstGeom prst="rect">
+            <a:avLst/>
+          </a:prstGeom>
+          <a:noFill/>
+          <a:ln/>
+        </p:spPr>
+        <p:txBody>
+          <a:bodyPr wrap="square" lIns="0" tIns="0" rIns="0" bIns="0" rtlCol="0" anchor="ctr"/>
+          <a:lstStyle/>
+          <a:p>
+            <a:pPr algn="r" indent="0" marL="0">
+              <a:buNone/>
+            </a:pPr>
+            <a:r>
+              <a:rPr lang="en-US" sz="1900" b="1" dirty="0">
+                <a:solidFill>
+                  <a:srgbClr val="0F7B6C"/>
+                </a:solidFill>
+                <a:latin typeface="Cambria" pitchFamily="34" charset="0"/>
+                <a:ea typeface="Cambria" pitchFamily="34" charset="-122"/>
+                <a:cs typeface="Cambria" pitchFamily="34" charset="-120"/>
+              </a:rPr>
+              <a:t>+41 萬顆／日</a:t>
+            </a:r>
+            <a:endParaRPr lang="en-US" sz="1900" dirty="0"/>
+          </a:p>
+        </p:txBody>
+      </p:sp>
+      <p:sp>
+        <p:nvSpPr>
+          <p:cNvPr id="11" name="Shape 9"/>
+          <p:cNvSpPr/>
+          <p:nvPr/>
+        </p:nvSpPr>
+        <p:spPr>
+          <a:xfrm>
+            <a:off x="566928" y="2587752"/>
+            <a:ext cx="11018520" cy="1051560"/>
+          </a:xfrm>
+          <a:prstGeom prst="roundRect">
+            <a:avLst>
+              <a:gd name="adj" fmla="val 4348"/>
+            </a:avLst>
+          </a:prstGeom>
+          <a:solidFill>
+            <a:srgbClr val="17254C"/>
+          </a:solidFill>
+          <a:ln w="12700">
+            <a:solidFill>
+              <a:srgbClr val="17254C"/>
+            </a:solidFill>
+            <a:prstDash val="solid"/>
+          </a:ln>
+        </p:spPr>
+      </p:sp>
+      <p:sp>
+        <p:nvSpPr>
+          <p:cNvPr id="12" name="Shape 10"/>
+          <p:cNvSpPr/>
+          <p:nvPr/>
+        </p:nvSpPr>
+        <p:spPr>
+          <a:xfrm>
+            <a:off x="841248" y="2898648"/>
+            <a:ext cx="429768" cy="429768"/>
+          </a:xfrm>
+          <a:prstGeom prst="ellipse">
+            <a:avLst/>
+          </a:prstGeom>
+          <a:solidFill>
+            <a:srgbClr val="0F7B6C"/>
+          </a:solidFill>
+          <a:ln w="12700">
+            <a:solidFill>
+              <a:srgbClr val="0F7B6C"/>
+            </a:solidFill>
+            <a:prstDash val="solid"/>
+          </a:ln>
+        </p:spPr>
+      </p:sp>
+      <p:sp>
+        <p:nvSpPr>
+          <p:cNvPr id="13" name="Text 11"/>
+          <p:cNvSpPr txBox="1"/>
+          <p:nvPr/>
+        </p:nvSpPr>
+        <p:spPr>
+          <a:xfrm>
+            <a:off x="841248" y="2935224"/>
+            <a:ext cx="429768" cy="365760"/>
+          </a:xfrm>
+          <a:prstGeom prst="rect">
+            <a:avLst/>
+          </a:prstGeom>
+          <a:noFill/>
+          <a:ln/>
+        </p:spPr>
+        <p:txBody>
+          <a:bodyPr wrap="square" lIns="0" tIns="0" rIns="0" bIns="0" rtlCol="0" anchor="ctr"/>
+          <a:lstStyle/>
+          <a:p>
+            <a:pPr algn="ctr" indent="0" marL="0">
+              <a:buNone/>
+            </a:pPr>
+            <a:r>
+              <a:rPr lang="en-US" sz="1600" b="1" dirty="0">
+                <a:solidFill>
+                  <a:srgbClr val="FFFFFF"/>
+                </a:solidFill>
+                <a:latin typeface="Calibri" pitchFamily="34" charset="0"/>
+                <a:ea typeface="Calibri" pitchFamily="34" charset="-122"/>
+                <a:cs typeface="Calibri" pitchFamily="34" charset="-120"/>
+              </a:rPr>
+              <a:t>2</a:t>
+            </a:r>
+            <a:endParaRPr lang="en-US" sz="1600" dirty="0"/>
+          </a:p>
+        </p:txBody>
+      </p:sp>
+      <p:sp>
+        <p:nvSpPr>
+          <p:cNvPr id="14" name="Text 12"/>
+          <p:cNvSpPr txBox="1"/>
+          <p:nvPr/>
+        </p:nvSpPr>
+        <p:spPr>
+          <a:xfrm>
+            <a:off x="1481328" y="2770632"/>
+            <a:ext cx="6583680" cy="365760"/>
+          </a:xfrm>
+          <a:prstGeom prst="rect">
+            <a:avLst/>
+          </a:prstGeom>
+          <a:noFill/>
+          <a:ln/>
+        </p:spPr>
+        <p:txBody>
+          <a:bodyPr wrap="square" lIns="0" tIns="0" rIns="0" bIns="0" rtlCol="0" anchor="ctr"/>
+          <a:lstStyle/>
+          <a:p>
+            <a:pPr indent="0" marL="0">
+              <a:buNone/>
+            </a:pPr>
+            <a:r>
+              <a:rPr lang="en-US" sz="1700" b="1" dirty="0">
+                <a:solidFill>
+                  <a:srgbClr val="FFFFFF"/>
+                </a:solidFill>
+                <a:latin typeface="Calibri" pitchFamily="34" charset="0"/>
+                <a:ea typeface="Calibri" pitchFamily="34" charset="-122"/>
+                <a:cs typeface="Calibri" pitchFamily="34" charset="-120"/>
+              </a:rPr>
+              <a:t>派工單不提前開，做完當下才決定</a:t>
+            </a:r>
+            <a:endParaRPr lang="en-US" sz="1700" dirty="0"/>
+          </a:p>
+        </p:txBody>
+      </p:sp>
+      <p:sp>
+        <p:nvSpPr>
+          <p:cNvPr id="15" name="Text 13"/>
+          <p:cNvSpPr txBox="1"/>
+          <p:nvPr/>
+        </p:nvSpPr>
+        <p:spPr>
+          <a:xfrm>
+            <a:off x="1481328" y="3154680"/>
+            <a:ext cx="6583680" cy="347472"/>
+          </a:xfrm>
+          <a:prstGeom prst="rect">
+            <a:avLst/>
+          </a:prstGeom>
+          <a:noFill/>
+          <a:ln/>
+        </p:spPr>
+        <p:txBody>
+          <a:bodyPr wrap="square" lIns="0" tIns="0" rIns="0" bIns="0" rtlCol="0" anchor="ctr"/>
+          <a:lstStyle/>
+          <a:p>
+            <a:pPr indent="0" marL="0">
+              <a:buNone/>
+            </a:pPr>
+            <a:r>
+              <a:rPr lang="en-US" sz="1250" dirty="0">
+                <a:solidFill>
+                  <a:srgbClr val="A9BBDD"/>
+                </a:solidFill>
+                <a:latin typeface="Calibri" pitchFamily="34" charset="0"/>
+                <a:ea typeface="Calibri" pitchFamily="34" charset="-122"/>
+                <a:cs typeface="Calibri" pitchFamily="34" charset="-120"/>
+              </a:rPr>
+              <a:t>取消預先押批，改為即時派工</a:t>
+            </a:r>
+            <a:endParaRPr lang="en-US" sz="1250" dirty="0"/>
+          </a:p>
+        </p:txBody>
+      </p:sp>
+      <p:sp>
+        <p:nvSpPr>
+          <p:cNvPr id="16" name="Text 14"/>
+          <p:cNvSpPr txBox="1"/>
+          <p:nvPr/>
+        </p:nvSpPr>
+        <p:spPr>
+          <a:xfrm>
+            <a:off x="8321040" y="2898648"/>
+            <a:ext cx="3063240" cy="457200"/>
+          </a:xfrm>
+          <a:prstGeom prst="rect">
+            <a:avLst/>
+          </a:prstGeom>
+          <a:noFill/>
+          <a:ln/>
+        </p:spPr>
+        <p:txBody>
+          <a:bodyPr wrap="square" lIns="0" tIns="0" rIns="0" bIns="0" rtlCol="0" anchor="ctr"/>
+          <a:lstStyle/>
+          <a:p>
+            <a:pPr algn="r" indent="0" marL="0">
+              <a:buNone/>
+            </a:pPr>
+            <a:r>
+              <a:rPr lang="en-US" sz="1900" b="1" dirty="0">
+                <a:solidFill>
+                  <a:srgbClr val="0F7B6C"/>
+                </a:solidFill>
+                <a:latin typeface="Cambria" pitchFamily="34" charset="0"/>
+                <a:ea typeface="Cambria" pitchFamily="34" charset="-122"/>
+                <a:cs typeface="Cambria" pitchFamily="34" charset="-120"/>
+              </a:rPr>
+              <a:t>+21 萬顆／日</a:t>
+            </a:r>
+            <a:endParaRPr lang="en-US" sz="1900" dirty="0"/>
+          </a:p>
+        </p:txBody>
+      </p:sp>
+      <p:sp>
+        <p:nvSpPr>
+          <p:cNvPr id="17" name="Shape 15"/>
+          <p:cNvSpPr/>
+          <p:nvPr/>
+        </p:nvSpPr>
+        <p:spPr>
+          <a:xfrm>
+            <a:off x="566928" y="3758184"/>
+            <a:ext cx="11018520" cy="1051560"/>
+          </a:xfrm>
+          <a:prstGeom prst="roundRect">
+            <a:avLst>
+              <a:gd name="adj" fmla="val 4348"/>
+            </a:avLst>
+          </a:prstGeom>
+          <a:solidFill>
+            <a:srgbClr val="17254C"/>
+          </a:solidFill>
+          <a:ln w="12700">
+            <a:solidFill>
+              <a:srgbClr val="17254C"/>
+            </a:solidFill>
+            <a:prstDash val="solid"/>
+          </a:ln>
+        </p:spPr>
+      </p:sp>
+      <p:sp>
+        <p:nvSpPr>
+          <p:cNvPr id="18" name="Shape 16"/>
+          <p:cNvSpPr/>
+          <p:nvPr/>
+        </p:nvSpPr>
+        <p:spPr>
+          <a:xfrm>
+            <a:off x="841248" y="4069080"/>
+            <a:ext cx="429768" cy="429768"/>
+          </a:xfrm>
+          <a:prstGeom prst="ellipse">
+            <a:avLst/>
+          </a:prstGeom>
+          <a:solidFill>
+            <a:srgbClr val="1C7293"/>
+          </a:solidFill>
+          <a:ln w="12700">
+            <a:solidFill>
+              <a:srgbClr val="1C7293"/>
+            </a:solidFill>
+            <a:prstDash val="solid"/>
+          </a:ln>
+        </p:spPr>
+      </p:sp>
+      <p:sp>
+        <p:nvSpPr>
+          <p:cNvPr id="19" name="Text 17"/>
+          <p:cNvSpPr txBox="1"/>
+          <p:nvPr/>
+        </p:nvSpPr>
+        <p:spPr>
+          <a:xfrm>
+            <a:off x="841248" y="4105656"/>
+            <a:ext cx="429768" cy="365760"/>
+          </a:xfrm>
+          <a:prstGeom prst="rect">
+            <a:avLst/>
+          </a:prstGeom>
+          <a:noFill/>
+          <a:ln/>
+        </p:spPr>
+        <p:txBody>
+          <a:bodyPr wrap="square" lIns="0" tIns="0" rIns="0" bIns="0" rtlCol="0" anchor="ctr"/>
+          <a:lstStyle/>
+          <a:p>
+            <a:pPr algn="ctr" indent="0" marL="0">
+              <a:buNone/>
+            </a:pPr>
+            <a:r>
+              <a:rPr lang="en-US" sz="1600" b="1" dirty="0">
+                <a:solidFill>
+                  <a:srgbClr val="FFFFFF"/>
+                </a:solidFill>
+                <a:latin typeface="Calibri" pitchFamily="34" charset="0"/>
+                <a:ea typeface="Calibri" pitchFamily="34" charset="-122"/>
+                <a:cs typeface="Calibri" pitchFamily="34" charset="-120"/>
+              </a:rPr>
+              <a:t>3</a:t>
+            </a:r>
+            <a:endParaRPr lang="en-US" sz="1600" dirty="0"/>
+          </a:p>
+        </p:txBody>
+      </p:sp>
+      <p:sp>
+        <p:nvSpPr>
+          <p:cNvPr id="20" name="Text 18"/>
+          <p:cNvSpPr txBox="1"/>
+          <p:nvPr/>
+        </p:nvSpPr>
+        <p:spPr>
+          <a:xfrm>
+            <a:off x="1481328" y="3941064"/>
+            <a:ext cx="6583680" cy="365760"/>
+          </a:xfrm>
+          <a:prstGeom prst="rect">
+            <a:avLst/>
+          </a:prstGeom>
+          <a:noFill/>
+          <a:ln/>
+        </p:spPr>
+        <p:txBody>
+          <a:bodyPr wrap="square" lIns="0" tIns="0" rIns="0" bIns="0" rtlCol="0" anchor="ctr"/>
+          <a:lstStyle/>
+          <a:p>
+            <a:pPr indent="0" marL="0">
+              <a:buNone/>
+            </a:pPr>
+            <a:r>
+              <a:rPr lang="en-US" sz="1700" b="1" dirty="0">
+                <a:solidFill>
+                  <a:srgbClr val="FFFFFF"/>
+                </a:solidFill>
+                <a:latin typeface="Calibri" pitchFamily="34" charset="0"/>
+                <a:ea typeface="Calibri" pitchFamily="34" charset="-122"/>
+                <a:cs typeface="Calibri" pitchFamily="34" charset="-120"/>
+              </a:rPr>
+              <a:t>工程師由 8 人補至 10 人（1:2.5）</a:t>
+            </a:r>
+            <a:endParaRPr lang="en-US" sz="1700" dirty="0"/>
+          </a:p>
+        </p:txBody>
+      </p:sp>
+      <p:sp>
+        <p:nvSpPr>
+          <p:cNvPr id="21" name="Text 19"/>
+          <p:cNvSpPr txBox="1"/>
+          <p:nvPr/>
+        </p:nvSpPr>
+        <p:spPr>
+          <a:xfrm>
+            <a:off x="1481328" y="4325112"/>
+            <a:ext cx="6583680" cy="347472"/>
+          </a:xfrm>
+          <a:prstGeom prst="rect">
+            <a:avLst/>
+          </a:prstGeom>
+          <a:noFill/>
+          <a:ln/>
+        </p:spPr>
+        <p:txBody>
+          <a:bodyPr wrap="square" lIns="0" tIns="0" rIns="0" bIns="0" rtlCol="0" anchor="ctr"/>
+          <a:lstStyle/>
+          <a:p>
+            <a:pPr indent="0" marL="0">
+              <a:buNone/>
+            </a:pPr>
+            <a:r>
+              <a:rPr lang="en-US" sz="1250" dirty="0">
+                <a:solidFill>
+                  <a:srgbClr val="A9BBDD"/>
+                </a:solidFill>
+                <a:latin typeface="Calibri" pitchFamily="34" charset="0"/>
+                <a:ea typeface="Calibri" pitchFamily="34" charset="-122"/>
+                <a:cs typeface="Calibri" pitchFamily="34" charset="-120"/>
+              </a:rPr>
+              <a:t>8 人時有 14.4% 的機台時間在停等</a:t>
+            </a:r>
+            <a:endParaRPr lang="en-US" sz="1250" dirty="0"/>
+          </a:p>
+        </p:txBody>
+      </p:sp>
+      <p:sp>
+        <p:nvSpPr>
+          <p:cNvPr id="22" name="Text 20"/>
+          <p:cNvSpPr txBox="1"/>
+          <p:nvPr/>
+        </p:nvSpPr>
+        <p:spPr>
+          <a:xfrm>
+            <a:off x="8321040" y="4069080"/>
+            <a:ext cx="3063240" cy="457200"/>
+          </a:xfrm>
+          <a:prstGeom prst="rect">
+            <a:avLst/>
+          </a:prstGeom>
+          <a:noFill/>
+          <a:ln/>
+        </p:spPr>
+        <p:txBody>
+          <a:bodyPr wrap="square" lIns="0" tIns="0" rIns="0" bIns="0" rtlCol="0" anchor="ctr"/>
+          <a:lstStyle/>
+          <a:p>
+            <a:pPr algn="r" indent="0" marL="0">
+              <a:buNone/>
+            </a:pPr>
+            <a:r>
+              <a:rPr lang="en-US" sz="1900" b="1" dirty="0">
+                <a:solidFill>
+                  <a:srgbClr val="1C7293"/>
+                </a:solidFill>
+                <a:latin typeface="Cambria" pitchFamily="34" charset="0"/>
+                <a:ea typeface="Cambria" pitchFamily="34" charset="-122"/>
+                <a:cs typeface="Cambria" pitchFamily="34" charset="-120"/>
+              </a:rPr>
+              <a:t>+7 萬顆／日</a:t>
+            </a:r>
+            <a:endParaRPr lang="en-US" sz="1900" dirty="0"/>
+          </a:p>
+        </p:txBody>
+      </p:sp>
+      <p:sp>
+        <p:nvSpPr>
+          <p:cNvPr id="23" name="Shape 21"/>
+          <p:cNvSpPr/>
+          <p:nvPr/>
+        </p:nvSpPr>
+        <p:spPr>
+          <a:xfrm>
+            <a:off x="566928" y="4928616"/>
+            <a:ext cx="11018520" cy="1051560"/>
+          </a:xfrm>
+          <a:prstGeom prst="roundRect">
+            <a:avLst>
+              <a:gd name="adj" fmla="val 4348"/>
+            </a:avLst>
+          </a:prstGeom>
+          <a:solidFill>
+            <a:srgbClr val="17254C"/>
+          </a:solidFill>
+          <a:ln w="12700">
+            <a:solidFill>
+              <a:srgbClr val="17254C"/>
+            </a:solidFill>
+            <a:prstDash val="solid"/>
+          </a:ln>
+        </p:spPr>
+      </p:sp>
+      <p:sp>
+        <p:nvSpPr>
+          <p:cNvPr id="24" name="Shape 22"/>
+          <p:cNvSpPr/>
+          <p:nvPr/>
+        </p:nvSpPr>
+        <p:spPr>
+          <a:xfrm>
+            <a:off x="841248" y="5239512"/>
+            <a:ext cx="429768" cy="429768"/>
+          </a:xfrm>
+          <a:prstGeom prst="ellipse">
+            <a:avLst/>
+          </a:prstGeom>
+          <a:solidFill>
+            <a:srgbClr val="1C7293"/>
+          </a:solidFill>
+          <a:ln w="12700">
+            <a:solidFill>
+              <a:srgbClr val="1C7293"/>
+            </a:solidFill>
+            <a:prstDash val="solid"/>
+          </a:ln>
+        </p:spPr>
+      </p:sp>
+      <p:sp>
+        <p:nvSpPr>
+          <p:cNvPr id="25" name="Text 23"/>
+          <p:cNvSpPr txBox="1"/>
+          <p:nvPr/>
+        </p:nvSpPr>
+        <p:spPr>
+          <a:xfrm>
+            <a:off x="841248" y="5276088"/>
+            <a:ext cx="429768" cy="365760"/>
+          </a:xfrm>
+          <a:prstGeom prst="rect">
+            <a:avLst/>
+          </a:prstGeom>
+          <a:noFill/>
+          <a:ln/>
+        </p:spPr>
+        <p:txBody>
+          <a:bodyPr wrap="square" lIns="0" tIns="0" rIns="0" bIns="0" rtlCol="0" anchor="ctr"/>
+          <a:lstStyle/>
+          <a:p>
+            <a:pPr algn="ctr" indent="0" marL="0">
+              <a:buNone/>
+            </a:pPr>
+            <a:r>
+              <a:rPr lang="en-US" sz="1600" b="1" dirty="0">
+                <a:solidFill>
+                  <a:srgbClr val="FFFFFF"/>
+                </a:solidFill>
+                <a:latin typeface="Calibri" pitchFamily="34" charset="0"/>
+                <a:ea typeface="Calibri" pitchFamily="34" charset="-122"/>
+                <a:cs typeface="Calibri" pitchFamily="34" charset="-120"/>
+              </a:rPr>
+              <a:t>4</a:t>
+            </a:r>
+            <a:endParaRPr lang="en-US" sz="1600" dirty="0"/>
+          </a:p>
+        </p:txBody>
+      </p:sp>
+      <p:sp>
+        <p:nvSpPr>
+          <p:cNvPr id="26" name="Text 24"/>
+          <p:cNvSpPr txBox="1"/>
+          <p:nvPr/>
+        </p:nvSpPr>
+        <p:spPr>
+          <a:xfrm>
+            <a:off x="1481328" y="5111496"/>
+            <a:ext cx="6583680" cy="365760"/>
+          </a:xfrm>
+          <a:prstGeom prst="rect">
+            <a:avLst/>
+          </a:prstGeom>
+          <a:noFill/>
+          <a:ln/>
+        </p:spPr>
+        <p:txBody>
+          <a:bodyPr wrap="square" lIns="0" tIns="0" rIns="0" bIns="0" rtlCol="0" anchor="ctr"/>
+          <a:lstStyle/>
+          <a:p>
+            <a:pPr indent="0" marL="0">
+              <a:buNone/>
+            </a:pPr>
+            <a:r>
+              <a:rPr lang="en-US" sz="1700" b="1" dirty="0">
+                <a:solidFill>
+                  <a:srgbClr val="FFFFFF"/>
+                </a:solidFill>
+                <a:latin typeface="Calibri" pitchFamily="34" charset="0"/>
+                <a:ea typeface="Calibri" pitchFamily="34" charset="-122"/>
+                <a:cs typeface="Calibri" pitchFamily="34" charset="-120"/>
+              </a:rPr>
+              <a:t>縮短換程式時間 30→15 分</a:t>
+            </a:r>
+            <a:endParaRPr lang="en-US" sz="1700" dirty="0"/>
+          </a:p>
+        </p:txBody>
+      </p:sp>
+      <p:sp>
+        <p:nvSpPr>
+          <p:cNvPr id="27" name="Text 25"/>
+          <p:cNvSpPr txBox="1"/>
+          <p:nvPr/>
+        </p:nvSpPr>
+        <p:spPr>
+          <a:xfrm>
+            <a:off x="1481328" y="5495544"/>
+            <a:ext cx="6583680" cy="347472"/>
+          </a:xfrm>
+          <a:prstGeom prst="rect">
+            <a:avLst/>
+          </a:prstGeom>
+          <a:noFill/>
+          <a:ln/>
+        </p:spPr>
+        <p:txBody>
+          <a:bodyPr wrap="square" lIns="0" tIns="0" rIns="0" bIns="0" rtlCol="0" anchor="ctr"/>
+          <a:lstStyle/>
+          <a:p>
+            <a:pPr indent="0" marL="0">
+              <a:buNone/>
+            </a:pPr>
+            <a:r>
+              <a:rPr lang="en-US" sz="1250" dirty="0">
+                <a:solidFill>
+                  <a:srgbClr val="A9BBDD"/>
+                </a:solidFill>
+                <a:latin typeface="Calibri" pitchFamily="34" charset="0"/>
+                <a:ea typeface="Calibri" pitchFamily="34" charset="-122"/>
+                <a:cs typeface="Calibri" pitchFamily="34" charset="-120"/>
+              </a:rPr>
+              <a:t>一天 213 次，槓桿最大的工程改善</a:t>
+            </a:r>
+            <a:endParaRPr lang="en-US" sz="1250" dirty="0"/>
+          </a:p>
+        </p:txBody>
+      </p:sp>
+      <p:sp>
+        <p:nvSpPr>
+          <p:cNvPr id="28" name="Text 26"/>
+          <p:cNvSpPr txBox="1"/>
+          <p:nvPr/>
+        </p:nvSpPr>
+        <p:spPr>
+          <a:xfrm>
+            <a:off x="8321040" y="5239512"/>
+            <a:ext cx="3063240" cy="457200"/>
+          </a:xfrm>
+          <a:prstGeom prst="rect">
+            <a:avLst/>
+          </a:prstGeom>
+          <a:noFill/>
+          <a:ln/>
+        </p:spPr>
+        <p:txBody>
+          <a:bodyPr wrap="square" lIns="0" tIns="0" rIns="0" bIns="0" rtlCol="0" anchor="ctr"/>
+          <a:lstStyle/>
+          <a:p>
+            <a:pPr algn="r" indent="0" marL="0">
+              <a:buNone/>
+            </a:pPr>
+            <a:r>
+              <a:rPr lang="en-US" sz="1900" b="1" dirty="0">
+                <a:solidFill>
+                  <a:srgbClr val="1C7293"/>
+                </a:solidFill>
+                <a:latin typeface="Cambria" pitchFamily="34" charset="0"/>
+                <a:ea typeface="Cambria" pitchFamily="34" charset="-122"/>
+                <a:cs typeface="Cambria" pitchFamily="34" charset="-120"/>
+              </a:rPr>
+              <a:t>+3 萬顆／日</a:t>
+            </a:r>
+            <a:endParaRPr lang="en-US" sz="1900" dirty="0"/>
+          </a:p>
+        </p:txBody>
+      </p:sp>
+      <p:sp>
+        <p:nvSpPr>
+          <p:cNvPr id="29" name="Text 27"/>
+          <p:cNvSpPr txBox="1"/>
+          <p:nvPr/>
+        </p:nvSpPr>
+        <p:spPr>
+          <a:xfrm>
+            <a:off x="566928" y="6035040"/>
+            <a:ext cx="11018520" cy="310896"/>
+          </a:xfrm>
+          <a:prstGeom prst="rect">
+            <a:avLst/>
+          </a:prstGeom>
+          <a:noFill/>
+          <a:ln/>
+        </p:spPr>
+        <p:txBody>
+          <a:bodyPr wrap="square" rtlCol="0" anchor="ctr"/>
+          <a:lstStyle/>
+          <a:p>
+            <a:pPr algn="ctr" indent="0" marL="0">
+              <a:buNone/>
+            </a:pPr>
+            <a:r>
+              <a:rPr lang="en-US" sz="1300" dirty="0">
+                <a:solidFill>
+                  <a:srgbClr val="CADCFC"/>
+                </a:solidFill>
+                <a:latin typeface="Calibri" pitchFamily="34" charset="0"/>
+                <a:ea typeface="Calibri" pitchFamily="34" charset="-122"/>
+                <a:cs typeface="Calibri" pitchFamily="34" charset="-120"/>
+              </a:rPr>
+              <a:t>四項全做：每日良品 77 萬 → 148 萬顆（+93%），逾期批數 220 批 → 2 批以下</a:t>
+            </a:r>
+            <a:endParaRPr lang="en-US" sz="1300" dirty="0"/>
+          </a:p>
+        </p:txBody>
+      </p:sp>
+      <p:sp>
+        <p:nvSpPr>
+          <p:cNvPr id="30" name="Text 28"/>
+          <p:cNvSpPr txBox="1"/>
+          <p:nvPr/>
+        </p:nvSpPr>
+        <p:spPr>
+          <a:xfrm>
+            <a:off x="566928" y="6345936"/>
+            <a:ext cx="11018520" cy="310896"/>
+          </a:xfrm>
+          <a:prstGeom prst="rect">
+            <a:avLst/>
+          </a:prstGeom>
+          <a:noFill/>
+          <a:ln/>
+        </p:spPr>
+        <p:txBody>
+          <a:bodyPr wrap="square" rtlCol="0" anchor="ctr"/>
+          <a:lstStyle/>
+          <a:p>
+            <a:pPr algn="ctr" indent="0" marL="0">
+              <a:buNone/>
+            </a:pPr>
+            <a:r>
+              <a:rPr lang="en-US" sz="1150" dirty="0">
+                <a:solidFill>
+                  <a:srgbClr val="A9BBDD"/>
+                </a:solidFill>
+                <a:latin typeface="Calibri" pitchFamily="34" charset="0"/>
+                <a:ea typeface="Calibri" pitchFamily="34" charset="-122"/>
+                <a:cs typeface="Calibri" pitchFamily="34" charset="-120"/>
+              </a:rPr>
+              <a:t>但第 1 項有前提：省改機是「人力吃緊」時的最佳解。人補到 1:2.5 之後，改用「大批給快機」更快——夜班與白班人數不同，規則就該不同。</a:t>
+            </a:r>
+            <a:endParaRPr lang="en-US" sz="1150" dirty="0"/>
+          </a:p>
+        </p:txBody>
+      </p:sp>
+    </p:spTree>
+  </p:cSld>
+  <p:clrMapOvr>
+    <a:masterClrMapping/>
+  </p:clrMapOvr>
+</p:sld>
+</file>
+
+<file path=ppt/slides/slide13.xml><?xml version="1.0" encoding="utf-8"?>
+<p:sld xmlns:a="http://schemas.openxmlformats.org/drawingml/2006/main" xmlns:r="http://schemas.openxmlformats.org/officeDocument/2006/relationships" xmlns:p="http://schemas.openxmlformats.org/presentationml/2006/main">
+  <p:cSld name="Slide 13">
+    <p:spTree>
+      <p:nvGrpSpPr>
+        <p:cNvPr id="1" name=""/>
+        <p:cNvGrpSpPr/>
+        <p:nvPr/>
+      </p:nvGrpSpPr>
+      <p:grpSpPr>
+        <a:xfrm>
+          <a:off x="0" y="0"/>
+          <a:ext cx="0" cy="0"/>
+          <a:chOff x="0" y="0"/>
+          <a:chExt cx="0" cy="0"/>
+        </a:xfrm>
+      </p:grpSpPr>
+      <p:sp>
+        <p:nvSpPr>
+          <p:cNvPr id="2" name="Text 0"/>
+          <p:cNvSpPr txBox="1"/>
+          <p:nvPr/>
+        </p:nvSpPr>
+        <p:spPr>
+          <a:xfrm>
+            <a:off x="566928" y="384048"/>
+            <a:ext cx="502920" cy="457200"/>
+          </a:xfrm>
+          <a:prstGeom prst="rect">
+            <a:avLst/>
+          </a:prstGeom>
+          <a:noFill/>
+          <a:ln/>
+        </p:spPr>
+        <p:txBody>
+          <a:bodyPr wrap="square" rtlCol="0" anchor="ctr"/>
+          <a:lstStyle/>
+          <a:p>
+            <a:pPr indent="0" marL="0">
+              <a:buNone/>
+            </a:pPr>
+            <a:r>
+              <a:rPr lang="en-US" sz="1300" b="1" dirty="0">
+                <a:solidFill>
+                  <a:srgbClr val="1C7293"/>
+                </a:solidFill>
+                <a:latin typeface="Calibri" pitchFamily="34" charset="0"/>
+                <a:ea typeface="Calibri" pitchFamily="34" charset="-122"/>
+                <a:cs typeface="Calibri" pitchFamily="34" charset="-120"/>
+              </a:rPr>
+              <a:t>12</a:t>
+            </a:r>
+            <a:endParaRPr lang="en-US" sz="1300" dirty="0"/>
+          </a:p>
+        </p:txBody>
+      </p:sp>
+      <p:sp>
+        <p:nvSpPr>
+          <p:cNvPr id="3" name="Text 1"/>
+          <p:cNvSpPr txBox="1"/>
+          <p:nvPr/>
+        </p:nvSpPr>
+        <p:spPr>
+          <a:xfrm>
+            <a:off x="1143000" y="310896"/>
+            <a:ext cx="10424160" cy="566928"/>
+          </a:xfrm>
+          <a:prstGeom prst="rect">
+            <a:avLst/>
+          </a:prstGeom>
+          <a:noFill/>
+          <a:ln/>
+        </p:spPr>
+        <p:txBody>
+          <a:bodyPr wrap="square" rtlCol="0" anchor="ctr"/>
+          <a:lstStyle/>
+          <a:p>
+            <a:pPr indent="0" marL="0">
+              <a:buNone/>
+            </a:pPr>
+            <a:r>
+              <a:rPr lang="en-US" sz="3000" b="1" dirty="0">
+                <a:solidFill>
+                  <a:srgbClr val="1E2761"/>
+                </a:solidFill>
+                <a:latin typeface="Cambria" pitchFamily="34" charset="0"/>
+                <a:ea typeface="Cambria" pitchFamily="34" charset="-122"/>
+                <a:cs typeface="Cambria" pitchFamily="34" charset="-120"/>
+              </a:rPr>
+              <a:t>實施路徑、追蹤指標與模型限制</a:t>
+            </a:r>
+            <a:endParaRPr lang="en-US" sz="3000" dirty="0"/>
+          </a:p>
+        </p:txBody>
+      </p:sp>
+      <p:sp>
+        <p:nvSpPr>
+          <p:cNvPr id="4" name="Text 2"/>
+          <p:cNvSpPr txBox="1"/>
+          <p:nvPr/>
+        </p:nvSpPr>
+        <p:spPr>
+          <a:xfrm>
+            <a:off x="1143000" y="896112"/>
+            <a:ext cx="10424160" cy="384048"/>
+          </a:xfrm>
+          <a:prstGeom prst="rect">
+            <a:avLst/>
+          </a:prstGeom>
+          <a:noFill/>
+          <a:ln/>
+        </p:spPr>
+        <p:txBody>
+          <a:bodyPr wrap="square" rtlCol="0" anchor="ctr"/>
+          <a:lstStyle/>
+          <a:p>
+            <a:pPr indent="0" marL="0">
+              <a:buNone/>
+            </a:pPr>
+            <a:r>
+              <a:rPr lang="en-US" sz="1350" dirty="0">
+                <a:solidFill>
+                  <a:srgbClr val="5A6785"/>
+                </a:solidFill>
+                <a:latin typeface="Calibri" pitchFamily="34" charset="0"/>
+                <a:ea typeface="Calibri" pitchFamily="34" charset="-122"/>
+                <a:cs typeface="Calibri" pitchFamily="34" charset="-120"/>
+              </a:rPr>
+              <a:t>建議以四週為一個驗證循環，每一步都有可量測的指標</a:t>
+            </a:r>
+            <a:endParaRPr lang="en-US" sz="1350" dirty="0"/>
+          </a:p>
+        </p:txBody>
+      </p:sp>
+      <p:sp>
+        <p:nvSpPr>
+          <p:cNvPr id="5" name="Shape 3"/>
+          <p:cNvSpPr/>
+          <p:nvPr/>
+        </p:nvSpPr>
+        <p:spPr>
+          <a:xfrm>
+            <a:off x="566928" y="1417320"/>
+            <a:ext cx="2670048" cy="2395728"/>
+          </a:xfrm>
+          <a:prstGeom prst="roundRect">
+            <a:avLst>
+              <a:gd name="adj" fmla="val 1908"/>
+            </a:avLst>
+          </a:prstGeom>
+          <a:solidFill>
+            <a:srgbClr val="F5F7FB"/>
+          </a:solidFill>
+          <a:ln w="12700">
+            <a:solidFill>
+              <a:srgbClr val="FFFFFF"/>
+            </a:solidFill>
+            <a:prstDash val="solid"/>
+          </a:ln>
+        </p:spPr>
+      </p:sp>
+      <p:sp>
+        <p:nvSpPr>
           <p:cNvPr id="6" name="Shape 4"/>
           <p:cNvSpPr/>
           <p:nvPr/>
@@ -3325,8 +4749,8 @@
         </p:nvSpPr>
         <p:spPr>
           <a:xfrm>
-            <a:off x="795528" y="3255264"/>
-            <a:ext cx="2240280" cy="566928"/>
+            <a:off x="795528" y="3200400"/>
+            <a:ext cx="2240280" cy="530352"/>
           </a:xfrm>
           <a:prstGeom prst="rect">
             <a:avLst/>
@@ -3368,11 +4792,11 @@
         <p:spPr>
           <a:xfrm>
             <a:off x="3419856" y="1417320"/>
-            <a:ext cx="2670048" cy="2560320"/>
+            <a:ext cx="2670048" cy="2395728"/>
           </a:xfrm>
           <a:prstGeom prst="roundRect">
             <a:avLst>
-              <a:gd name="adj" fmla="val 1786"/>
+              <a:gd name="adj" fmla="val 1908"/>
             </a:avLst>
           </a:prstGeom>
           <a:solidFill>
@@ -3578,8 +5002,8 @@
         </p:nvSpPr>
         <p:spPr>
           <a:xfrm>
-            <a:off x="3648456" y="3255264"/>
-            <a:ext cx="2240280" cy="566928"/>
+            <a:off x="3648456" y="3200400"/>
+            <a:ext cx="2240280" cy="530352"/>
           </a:xfrm>
           <a:prstGeom prst="rect">
             <a:avLst/>
@@ -3621,11 +5045,11 @@
         <p:spPr>
           <a:xfrm>
             <a:off x="6272784" y="1417320"/>
-            <a:ext cx="2670048" cy="2560320"/>
+            <a:ext cx="2670048" cy="2395728"/>
           </a:xfrm>
           <a:prstGeom prst="roundRect">
             <a:avLst>
-              <a:gd name="adj" fmla="val 1786"/>
+              <a:gd name="adj" fmla="val 1908"/>
             </a:avLst>
           </a:prstGeom>
           <a:solidFill>
@@ -3831,8 +5255,8 @@
         </p:nvSpPr>
         <p:spPr>
           <a:xfrm>
-            <a:off x="6501384" y="3255264"/>
-            <a:ext cx="2240280" cy="566928"/>
+            <a:off x="6501384" y="3200400"/>
+            <a:ext cx="2240280" cy="530352"/>
           </a:xfrm>
           <a:prstGeom prst="rect">
             <a:avLst/>
@@ -3874,11 +5298,11 @@
         <p:spPr>
           <a:xfrm>
             <a:off x="9125712" y="1417320"/>
-            <a:ext cx="2670048" cy="2560320"/>
+            <a:ext cx="2670048" cy="2395728"/>
           </a:xfrm>
           <a:prstGeom prst="roundRect">
             <a:avLst>
-              <a:gd name="adj" fmla="val 1786"/>
+              <a:gd name="adj" fmla="val 1908"/>
             </a:avLst>
           </a:prstGeom>
           <a:solidFill>
@@ -4084,8 +5508,8 @@
         </p:nvSpPr>
         <p:spPr>
           <a:xfrm>
-            <a:off x="9354312" y="3255264"/>
-            <a:ext cx="2240280" cy="566928"/>
+            <a:off x="9354312" y="3200400"/>
+            <a:ext cx="2240280" cy="530352"/>
           </a:xfrm>
           <a:prstGeom prst="rect">
             <a:avLst/>
@@ -4126,12 +5550,12 @@
         </p:nvSpPr>
         <p:spPr>
           <a:xfrm>
-            <a:off x="566928" y="4133088"/>
-            <a:ext cx="5486400" cy="1920240"/>
+            <a:off x="566928" y="3968496"/>
+            <a:ext cx="5486400" cy="2157984"/>
           </a:xfrm>
           <a:prstGeom prst="roundRect">
             <a:avLst>
-              <a:gd name="adj" fmla="val 2381"/>
+              <a:gd name="adj" fmla="val 2119"/>
             </a:avLst>
           </a:prstGeom>
           <a:solidFill>
@@ -4153,7 +5577,7 @@
         </p:nvSpPr>
         <p:spPr>
           <a:xfrm>
-            <a:off x="804672" y="4389120"/>
+            <a:off x="804672" y="4224528"/>
             <a:ext cx="146304" cy="146304"/>
           </a:xfrm>
           <a:prstGeom prst="ellipse">
@@ -4178,7 +5602,7 @@
         </p:nvSpPr>
         <p:spPr>
           <a:xfrm>
-            <a:off x="1060704" y="4288536"/>
+            <a:off x="1060704" y="4123944"/>
             <a:ext cx="4754880" cy="329184"/>
           </a:xfrm>
           <a:prstGeom prst="rect">
@@ -4217,8 +5641,8 @@
         </p:nvSpPr>
         <p:spPr>
           <a:xfrm>
-            <a:off x="1060704" y="4645152"/>
-            <a:ext cx="4754880" cy="1316736"/>
+            <a:off x="1060704" y="4480560"/>
+            <a:ext cx="4754880" cy="1554480"/>
           </a:xfrm>
           <a:prstGeom prst="rect">
             <a:avLst/>
@@ -4335,12 +5759,12 @@
         </p:nvSpPr>
         <p:spPr>
           <a:xfrm>
-            <a:off x="6172200" y="4133088"/>
-            <a:ext cx="5413248" cy="1920240"/>
+            <a:off x="6172200" y="3968496"/>
+            <a:ext cx="5413248" cy="2157984"/>
           </a:xfrm>
           <a:prstGeom prst="roundRect">
             <a:avLst>
-              <a:gd name="adj" fmla="val 2381"/>
+              <a:gd name="adj" fmla="val 2119"/>
             </a:avLst>
           </a:prstGeom>
           <a:solidFill>
@@ -4362,7 +5786,7 @@
         </p:nvSpPr>
         <p:spPr>
           <a:xfrm>
-            <a:off x="6409944" y="4389120"/>
+            <a:off x="6409944" y="4224528"/>
             <a:ext cx="146304" cy="146304"/>
           </a:xfrm>
           <a:prstGeom prst="ellipse">
@@ -4387,7 +5811,7 @@
         </p:nvSpPr>
         <p:spPr>
           <a:xfrm>
-            <a:off x="6665976" y="4288536"/>
+            <a:off x="6665976" y="4123944"/>
             <a:ext cx="4681728" cy="329184"/>
           </a:xfrm>
           <a:prstGeom prst="rect">
@@ -4426,8 +5850,8 @@
         </p:nvSpPr>
         <p:spPr>
           <a:xfrm>
-            <a:off x="6665976" y="4645152"/>
-            <a:ext cx="4681728" cy="1316736"/>
+            <a:off x="6665976" y="4480560"/>
+            <a:ext cx="4681728" cy="1554480"/>
           </a:xfrm>
           <a:prstGeom prst="rect">
             <a:avLst/>
@@ -4458,7 +5882,7 @@
                 <a:ea typeface="Calibri" pitchFamily="34" charset="-122"/>
                 <a:cs typeface="Calibri" pitchFamily="34" charset="-120"/>
               </a:rPr>
-              <a:t>每台機實際日完成批數（核對稼動率 46.7%）</a:t>
+              <a:t>實際的 WIP 清單（第 9~10 頁用模擬資料）</a:t>
             </a:r>
             <a:endParaRPr lang="en-US" sz="1200" dirty="0"/>
           </a:p>
@@ -4482,7 +5906,7 @@
                 <a:ea typeface="Calibri" pitchFamily="34" charset="-122"/>
                 <a:cs typeface="Calibri" pitchFamily="34" charset="-120"/>
               </a:rPr>
-              <a:t>逾期一批的真實違約成本（現以 20,000 代入）</a:t>
+              <a:t>每台機實際日完成批數（核對稼動率 46.7%）</a:t>
             </a:r>
             <a:endParaRPr lang="en-US" sz="1200" dirty="0"/>
           </a:p>
@@ -4506,6 +5930,30 @@
                 <a:ea typeface="Calibri" pitchFamily="34" charset="-122"/>
                 <a:cs typeface="Calibri" pitchFamily="34" charset="-120"/>
               </a:rPr>
+              <a:t>逾期一批的真實違約成本（現以 20,000 代入）</a:t>
+            </a:r>
+            <a:endParaRPr lang="en-US" sz="1200" dirty="0"/>
+          </a:p>
+          <a:p>
+            <a:pPr marL="342900" indent="-342900">
+              <a:lnSpc>
+                <a:spcPts val="1800"/>
+              </a:lnSpc>
+              <a:spcAft>
+                <a:spcPts val="400"/>
+              </a:spcAft>
+              <a:buSzPct val="100000"/>
+              <a:buChar char="•"/>
+            </a:pPr>
+            <a:r>
+              <a:rPr lang="en-US" sz="1200" dirty="0">
+                <a:solidFill>
+                  <a:srgbClr val="16213E"/>
+                </a:solidFill>
+                <a:latin typeface="Calibri" pitchFamily="34" charset="0"/>
+                <a:ea typeface="Calibri" pitchFamily="34" charset="-122"/>
+                <a:cs typeface="Calibri" pitchFamily="34" charset="-120"/>
+              </a:rPr>
               <a:t>換程式是否一律由工程師執行——若由操作員執行，人力需求可由 10 人降至 5～6 人</a:t>
             </a:r>
             <a:endParaRPr lang="en-US" sz="1200" dirty="0"/>
@@ -4520,8 +5968,8 @@
         </p:nvSpPr>
         <p:spPr>
           <a:xfrm>
-            <a:off x="566928" y="6181344"/>
-            <a:ext cx="11018520" cy="384048"/>
+            <a:off x="566928" y="6217920"/>
+            <a:ext cx="11018520" cy="365760"/>
           </a:xfrm>
           <a:prstGeom prst="rect">
             <a:avLst/>

</xml_diff>

<commit_message>
Add the fleet-scale finding to the report
Running the same 90-lot backlog on the real 25-machine fleet reverses
the previous slide's conclusion a second time: minimising changeovers
wins on five machines (14.6h vs 29.4h) and loses on twenty-five
(7.9h vs 6.4h). With machines to spare the bottleneck stops being the
changeover queue and becomes whether the big lots reach the 8-site
machines.

The second chart is the one worth acting on. Re-binding the twenty
dedicated machines to match this backlog's mix — same machine count,
same site structure — barely moves the best rule (6.4h to 6.6h) but
pulls the worst from 19.8h to 12.5h, and drops engineer waiting to zero
everywhere. Aligning the configuration buys tolerance for picking the
wrong rule, not speed.

Both datasets are committed so the numbers can be reproduced.

Co-Authored-By: Claude Opus 5 <noreply@anthropic.com>
Claude-Session: https://claude.ai/code/session_01TrwTqMZ3kHRLL23LGZ4TZk
</commit_message>
<xml_diff>
--- a/docs/測試排程分析報告.pptx
+++ b/docs/測試排程分析報告.pptx
@@ -18,9 +18,10 @@
     <p:sldId id="266" r:id="rId12"/>
     <p:sldId id="267" r:id="rId13"/>
     <p:sldId id="268" r:id="rId14"/>
+    <p:sldId id="269" r:id="rId15"/>
   </p:sldIdLst>
   <p:notesMasterIdLst>
-    <p:notesMasterId r:id="rId15"/>
+    <p:notesMasterId r:id="rId16"/>
   </p:notesMasterIdLst>
   <p:sldSz cx="12192000" cy="6858000"/>
   <p:notesSz cx="6858000" cy="12192000"/>
@@ -778,7 +779,7 @@
           <a:p>
             <a:r>
               <a:rPr lang="en-US" dirty="0"/>
-              <a:t>前兩項是純管理決策，今天就能改；第三項是人力預算；第四項需要 IT 或設備工程投入。</a:t>
+              <a:t>5 台機時瓶頸是改機排隊，所以省改機贏；25 台機時機台過剩、瓶頸變成有沒有把大批塞進 8-site 快機。重新對齊後所有法則的等工程師時間都是 0。</a:t>
             </a:r>
             <a:endParaRPr lang="en-US" dirty="0"/>
           </a:p>
@@ -866,7 +867,7 @@
           <a:p>
             <a:r>
               <a:rPr lang="en-US" dirty="0"/>
-              <a:t>四個階段刻意分開，避免同時變動多個變數而無法歸因。最大的單一不確定性是換程式是否佔用工程師。</a:t>
+              <a:t>前兩項是純管理決策，今天就能改；第三項是人力預算；第四項需要 IT 或設備工程投入。</a:t>
             </a:r>
             <a:endParaRPr lang="en-US" dirty="0"/>
           </a:p>
@@ -890,6 +891,94 @@
             <a:fld id="{F7021451-1387-4CA6-816F-3879F97B5CBC}" type="slidenum">
               <a:rPr lang="en-US"/>
               <a:t>13</a:t>
+            </a:fld>
+            <a:endParaRPr lang="en-US"/>
+          </a:p>
+        </p:txBody>
+      </p:sp>
+    </p:spTree>
+    <p:extLst>
+      <p:ext uri="{BB962C8B-B14F-4D97-AF65-F5344CB8AC3E}">
+        <p14:creationId xmlns:p14="http://schemas.microsoft.com/office/powerpoint/2010/main" val="1024086991"/>
+      </p:ext>
+    </p:extLst>
+  </p:cSld>
+  <p:clrMapOvr>
+    <a:masterClrMapping/>
+  </p:clrMapOvr>
+</p:notes>
+</file>
+
+<file path=ppt/notesSlides/notesSlide14.xml><?xml version="1.0" encoding="utf-8"?>
+<p:notes xmlns:a="http://schemas.openxmlformats.org/drawingml/2006/main" xmlns:r="http://schemas.openxmlformats.org/officeDocument/2006/relationships" xmlns:p="http://schemas.openxmlformats.org/presentationml/2006/main">
+  <p:cSld>
+    <p:spTree>
+      <p:nvGrpSpPr>
+        <p:cNvPr id="1" name=""/>
+        <p:cNvGrpSpPr/>
+        <p:nvPr/>
+      </p:nvGrpSpPr>
+      <p:grpSpPr>
+        <a:xfrm>
+          <a:off x="0" y="0"/>
+          <a:ext cx="0" cy="0"/>
+          <a:chOff x="0" y="0"/>
+          <a:chExt cx="0" cy="0"/>
+        </a:xfrm>
+      </p:grpSpPr>
+      <p:sp>
+        <p:nvSpPr>
+          <p:cNvPr id="2" name="Slide Image Placeholder 1"/>
+          <p:cNvSpPr>
+            <a:spLocks noGrp="1" noRot="1" noChangeAspect="1"/>
+          </p:cNvSpPr>
+          <p:nvPr>
+            <p:ph type="sldImg"/>
+          </p:nvPr>
+        </p:nvSpPr>
+        <p:spPr/>
+      </p:sp>
+      <p:sp>
+        <p:nvSpPr>
+          <p:cNvPr id="3" name="Notes Placeholder 2"/>
+          <p:cNvSpPr>
+            <a:spLocks noGrp="1"/>
+          </p:cNvSpPr>
+          <p:nvPr>
+            <p:ph type="body" idx="1"/>
+          </p:nvPr>
+        </p:nvSpPr>
+        <p:spPr/>
+        <p:txBody>
+          <a:bodyPr/>
+          <a:lstStyle/>
+          <a:p>
+            <a:r>
+              <a:rPr lang="en-US" dirty="0"/>
+              <a:t>四個階段刻意分開，避免同時變動多個變數而無法歸因。最大的單一不確定性是換程式是否佔用工程師。</a:t>
+            </a:r>
+            <a:endParaRPr lang="en-US" dirty="0"/>
+          </a:p>
+        </p:txBody>
+      </p:sp>
+      <p:sp>
+        <p:nvSpPr>
+          <p:cNvPr id="4" name="Slide Number Placeholder 3"/>
+          <p:cNvSpPr>
+            <a:spLocks noGrp="1"/>
+          </p:cNvSpPr>
+          <p:nvPr>
+            <p:ph type="sldNum" sz="quarter" idx="10"/>
+          </p:nvPr>
+        </p:nvSpPr>
+        <p:spPr/>
+        <p:txBody>
+          <a:bodyPr/>
+          <a:lstStyle/>
+          <a:p>
+            <a:fld id="{F7021451-1387-4CA6-816F-3879F97B5CBC}" type="slidenum">
+              <a:rPr lang="en-US"/>
+              <a:t>14</a:t>
             </a:fld>
             <a:endParaRPr lang="en-US"/>
           </a:p>
@@ -3340,6 +3429,605 @@
 <file path=ppt/slides/slide12.xml><?xml version="1.0" encoding="utf-8"?>
 <p:sld xmlns:a="http://schemas.openxmlformats.org/drawingml/2006/main" xmlns:r="http://schemas.openxmlformats.org/officeDocument/2006/relationships" xmlns:p="http://schemas.openxmlformats.org/presentationml/2006/main">
   <p:cSld name="Slide 12">
+    <p:spTree>
+      <p:nvGrpSpPr>
+        <p:cNvPr id="1" name=""/>
+        <p:cNvGrpSpPr/>
+        <p:nvPr/>
+      </p:nvGrpSpPr>
+      <p:grpSpPr>
+        <a:xfrm>
+          <a:off x="0" y="0"/>
+          <a:ext cx="0" cy="0"/>
+          <a:chOff x="0" y="0"/>
+          <a:chExt cx="0" cy="0"/>
+        </a:xfrm>
+      </p:grpSpPr>
+      <p:sp>
+        <p:nvSpPr>
+          <p:cNvPr id="2" name="Text 0"/>
+          <p:cNvSpPr txBox="1"/>
+          <p:nvPr/>
+        </p:nvSpPr>
+        <p:spPr>
+          <a:xfrm>
+            <a:off x="566928" y="384048"/>
+            <a:ext cx="502920" cy="457200"/>
+          </a:xfrm>
+          <a:prstGeom prst="rect">
+            <a:avLst/>
+          </a:prstGeom>
+          <a:noFill/>
+          <a:ln/>
+        </p:spPr>
+        <p:txBody>
+          <a:bodyPr wrap="square" rtlCol="0" anchor="ctr"/>
+          <a:lstStyle/>
+          <a:p>
+            <a:pPr indent="0" marL="0">
+              <a:buNone/>
+            </a:pPr>
+            <a:r>
+              <a:rPr lang="en-US" sz="1300" b="1" dirty="0">
+                <a:solidFill>
+                  <a:srgbClr val="1C7293"/>
+                </a:solidFill>
+                <a:latin typeface="Calibri" pitchFamily="34" charset="0"/>
+                <a:ea typeface="Calibri" pitchFamily="34" charset="-122"/>
+                <a:cs typeface="Calibri" pitchFamily="34" charset="-120"/>
+              </a:rPr>
+              <a:t>11</a:t>
+            </a:r>
+            <a:endParaRPr lang="en-US" sz="1300" dirty="0"/>
+          </a:p>
+        </p:txBody>
+      </p:sp>
+      <p:sp>
+        <p:nvSpPr>
+          <p:cNvPr id="3" name="Text 1"/>
+          <p:cNvSpPr txBox="1"/>
+          <p:nvPr/>
+        </p:nvSpPr>
+        <p:spPr>
+          <a:xfrm>
+            <a:off x="1143000" y="310896"/>
+            <a:ext cx="10424160" cy="566928"/>
+          </a:xfrm>
+          <a:prstGeom prst="rect">
+            <a:avLst/>
+          </a:prstGeom>
+          <a:noFill/>
+          <a:ln/>
+        </p:spPr>
+        <p:txBody>
+          <a:bodyPr wrap="square" rtlCol="0" anchor="ctr"/>
+          <a:lstStyle/>
+          <a:p>
+            <a:pPr indent="0" marL="0">
+              <a:buNone/>
+            </a:pPr>
+            <a:r>
+              <a:rPr lang="en-US" sz="3000" b="1" dirty="0">
+                <a:solidFill>
+                  <a:srgbClr val="1E2761"/>
+                </a:solidFill>
+                <a:latin typeface="Cambria" pitchFamily="34" charset="0"/>
+                <a:ea typeface="Cambria" pitchFamily="34" charset="-122"/>
+                <a:cs typeface="Cambria" pitchFamily="34" charset="-120"/>
+              </a:rPr>
+              <a:t>機隊規模與專用機配置也會換掉答案</a:t>
+            </a:r>
+            <a:endParaRPr lang="en-US" sz="3000" dirty="0"/>
+          </a:p>
+        </p:txBody>
+      </p:sp>
+      <p:sp>
+        <p:nvSpPr>
+          <p:cNvPr id="4" name="Text 2"/>
+          <p:cNvSpPr txBox="1"/>
+          <p:nvPr/>
+        </p:nvSpPr>
+        <p:spPr>
+          <a:xfrm>
+            <a:off x="1143000" y="896112"/>
+            <a:ext cx="10424160" cy="384048"/>
+          </a:xfrm>
+          <a:prstGeom prst="rect">
+            <a:avLst/>
+          </a:prstGeom>
+          <a:noFill/>
+          <a:ln/>
+        </p:spPr>
+        <p:txBody>
+          <a:bodyPr wrap="square" rtlCol="0" anchor="ctr"/>
+          <a:lstStyle/>
+          <a:p>
+            <a:pPr indent="0" marL="0">
+              <a:buNone/>
+            </a:pPr>
+            <a:r>
+              <a:rPr lang="en-US" sz="1350" dirty="0">
+                <a:solidFill>
+                  <a:srgbClr val="5A6785"/>
+                </a:solidFill>
+                <a:latin typeface="Calibri" pitchFamily="34" charset="0"/>
+                <a:ea typeface="Calibri" pitchFamily="34" charset="-122"/>
+                <a:cs typeface="Calibri" pitchFamily="34" charset="-120"/>
+              </a:rPr>
+              <a:t>同一批 90 批 WIP，把 5 台機換成真實的 25 台機隊（機隊 100 site、10 位工程師）重跑一次</a:t>
+            </a:r>
+            <a:endParaRPr lang="en-US" sz="1350" dirty="0"/>
+          </a:p>
+        </p:txBody>
+      </p:sp>
+      <p:pic>
+        <p:nvPicPr>
+          <p:cNvPr id="5" name="Image 0" descr="charts/c_fleet.png">    </p:cNvPr>
+          <p:cNvPicPr>
+            <a:picLocks noChangeAspect="1"/>
+          </p:cNvPicPr>
+          <p:nvPr/>
+        </p:nvPicPr>
+        <p:blipFill>
+          <a:blip r:embed="rId1"/>
+          <a:stretch>
+            <a:fillRect/>
+          </a:stretch>
+        </p:blipFill>
+        <p:spPr>
+          <a:xfrm>
+            <a:off x="566928" y="1316736"/>
+            <a:ext cx="5029200" cy="3455545"/>
+          </a:xfrm>
+          <a:prstGeom prst="rect">
+            <a:avLst/>
+          </a:prstGeom>
+        </p:spPr>
+      </p:pic>
+      <p:pic>
+        <p:nvPicPr>
+          <p:cNvPr id="6" name="Image 1" descr="charts/c_rematch.png">    </p:cNvPr>
+          <p:cNvPicPr>
+            <a:picLocks noChangeAspect="1"/>
+          </p:cNvPicPr>
+          <p:nvPr/>
+        </p:nvPicPr>
+        <p:blipFill>
+          <a:blip r:embed="rId2"/>
+          <a:stretch>
+            <a:fillRect/>
+          </a:stretch>
+        </p:blipFill>
+        <p:spPr>
+          <a:xfrm>
+            <a:off x="6592824" y="1316736"/>
+            <a:ext cx="5029200" cy="3455545"/>
+          </a:xfrm>
+          <a:prstGeom prst="rect">
+            <a:avLst/>
+          </a:prstGeom>
+        </p:spPr>
+      </p:pic>
+      <p:sp>
+        <p:nvSpPr>
+          <p:cNvPr id="7" name="Shape 3"/>
+          <p:cNvSpPr/>
+          <p:nvPr/>
+        </p:nvSpPr>
+        <p:spPr>
+          <a:xfrm>
+            <a:off x="566928" y="4846320"/>
+            <a:ext cx="5486400" cy="1481328"/>
+          </a:xfrm>
+          <a:prstGeom prst="roundRect">
+            <a:avLst>
+              <a:gd name="adj" fmla="val 3086"/>
+            </a:avLst>
+          </a:prstGeom>
+          <a:solidFill>
+            <a:srgbClr val="F5F7FB"/>
+          </a:solidFill>
+          <a:ln w="12700">
+            <a:solidFill>
+              <a:srgbClr val="FFFFFF"/>
+            </a:solidFill>
+            <a:prstDash val="solid"/>
+          </a:ln>
+        </p:spPr>
+      </p:sp>
+      <p:sp>
+        <p:nvSpPr>
+          <p:cNvPr id="8" name="Shape 4"/>
+          <p:cNvSpPr/>
+          <p:nvPr/>
+        </p:nvSpPr>
+        <p:spPr>
+          <a:xfrm>
+            <a:off x="804672" y="5102352"/>
+            <a:ext cx="146304" cy="146304"/>
+          </a:xfrm>
+          <a:prstGeom prst="ellipse">
+            <a:avLst/>
+          </a:prstGeom>
+          <a:solidFill>
+            <a:srgbClr val="C2410C"/>
+          </a:solidFill>
+          <a:ln w="12700">
+            <a:solidFill>
+              <a:srgbClr val="C2410C"/>
+            </a:solidFill>
+            <a:prstDash val="solid"/>
+          </a:ln>
+        </p:spPr>
+      </p:sp>
+      <p:sp>
+        <p:nvSpPr>
+          <p:cNvPr id="9" name="Text 5"/>
+          <p:cNvSpPr txBox="1"/>
+          <p:nvPr/>
+        </p:nvSpPr>
+        <p:spPr>
+          <a:xfrm>
+            <a:off x="1060704" y="5001768"/>
+            <a:ext cx="4754880" cy="329184"/>
+          </a:xfrm>
+          <a:prstGeom prst="rect">
+            <a:avLst/>
+          </a:prstGeom>
+          <a:noFill/>
+          <a:ln/>
+        </p:spPr>
+        <p:txBody>
+          <a:bodyPr wrap="square" lIns="0" tIns="0" rIns="0" bIns="0" rtlCol="0" anchor="ctr"/>
+          <a:lstStyle/>
+          <a:p>
+            <a:pPr indent="0" marL="0">
+              <a:buNone/>
+            </a:pPr>
+            <a:r>
+              <a:rPr lang="en-US" sz="1450" b="1" dirty="0">
+                <a:solidFill>
+                  <a:srgbClr val="1E2761"/>
+                </a:solidFill>
+                <a:latin typeface="Calibri" pitchFamily="34" charset="0"/>
+                <a:ea typeface="Calibri" pitchFamily="34" charset="-122"/>
+                <a:cs typeface="Calibri" pitchFamily="34" charset="-120"/>
+              </a:rPr>
+              <a:t>機台越多，省改機越不是答案</a:t>
+            </a:r>
+            <a:endParaRPr lang="en-US" sz="1450" dirty="0"/>
+          </a:p>
+        </p:txBody>
+      </p:sp>
+      <p:sp>
+        <p:nvSpPr>
+          <p:cNvPr id="10" name="Text 6"/>
+          <p:cNvSpPr txBox="1"/>
+          <p:nvPr/>
+        </p:nvSpPr>
+        <p:spPr>
+          <a:xfrm>
+            <a:off x="1060704" y="5358384"/>
+            <a:ext cx="4754880" cy="877824"/>
+          </a:xfrm>
+          <a:prstGeom prst="rect">
+            <a:avLst/>
+          </a:prstGeom>
+          <a:noFill/>
+          <a:ln/>
+        </p:spPr>
+        <p:txBody>
+          <a:bodyPr wrap="square" lIns="0" tIns="0" rIns="0" bIns="0" rtlCol="0" anchor="ctr"/>
+          <a:lstStyle/>
+          <a:p>
+            <a:pPr marL="342900" indent="-342900">
+              <a:lnSpc>
+                <a:spcPts val="1800"/>
+              </a:lnSpc>
+              <a:spcAft>
+                <a:spcPts val="400"/>
+              </a:spcAft>
+              <a:buSzPct val="100000"/>
+              <a:buChar char="•"/>
+            </a:pPr>
+            <a:r>
+              <a:rPr lang="en-US" sz="1200" dirty="0">
+                <a:solidFill>
+                  <a:srgbClr val="16213E"/>
+                </a:solidFill>
+                <a:latin typeface="Calibri" pitchFamily="34" charset="0"/>
+                <a:ea typeface="Calibri" pitchFamily="34" charset="-122"/>
+                <a:cs typeface="Calibri" pitchFamily="34" charset="-120"/>
+              </a:rPr>
+              <a:t>5 台機：省改機 14.6 h 勝，大批給快機 29.4 h</a:t>
+            </a:r>
+            <a:endParaRPr lang="en-US" sz="1200" dirty="0"/>
+          </a:p>
+          <a:p>
+            <a:pPr marL="342900" indent="-342900">
+              <a:lnSpc>
+                <a:spcPts val="1800"/>
+              </a:lnSpc>
+              <a:spcAft>
+                <a:spcPts val="400"/>
+              </a:spcAft>
+              <a:buSzPct val="100000"/>
+              <a:buChar char="•"/>
+            </a:pPr>
+            <a:r>
+              <a:rPr lang="en-US" sz="1200" dirty="0">
+                <a:solidFill>
+                  <a:srgbClr val="16213E"/>
+                </a:solidFill>
+                <a:latin typeface="Calibri" pitchFamily="34" charset="0"/>
+                <a:ea typeface="Calibri" pitchFamily="34" charset="-122"/>
+                <a:cs typeface="Calibri" pitchFamily="34" charset="-120"/>
+              </a:rPr>
+              <a:t>25 台機：大批給快機 6.4 h，省改機退到 7.9 h</a:t>
+            </a:r>
+            <a:endParaRPr lang="en-US" sz="1200" dirty="0"/>
+          </a:p>
+          <a:p>
+            <a:pPr marL="342900" indent="-342900">
+              <a:lnSpc>
+                <a:spcPts val="1800"/>
+              </a:lnSpc>
+              <a:spcAft>
+                <a:spcPts val="400"/>
+              </a:spcAft>
+              <a:buSzPct val="100000"/>
+              <a:buChar char="•"/>
+            </a:pPr>
+            <a:r>
+              <a:rPr lang="en-US" sz="1200" dirty="0">
+                <a:solidFill>
+                  <a:srgbClr val="16213E"/>
+                </a:solidFill>
+                <a:latin typeface="Calibri" pitchFamily="34" charset="0"/>
+                <a:ea typeface="Calibri" pitchFamily="34" charset="-122"/>
+                <a:cs typeface="Calibri" pitchFamily="34" charset="-120"/>
+              </a:rPr>
+              <a:t>機台少 → 改機排隊；機台多 → 快機沒用滿</a:t>
+            </a:r>
+            <a:endParaRPr lang="en-US" sz="1200" dirty="0"/>
+          </a:p>
+        </p:txBody>
+      </p:sp>
+      <p:sp>
+        <p:nvSpPr>
+          <p:cNvPr id="11" name="Shape 7"/>
+          <p:cNvSpPr/>
+          <p:nvPr/>
+        </p:nvSpPr>
+        <p:spPr>
+          <a:xfrm>
+            <a:off x="6172200" y="4846320"/>
+            <a:ext cx="5449824" cy="1481328"/>
+          </a:xfrm>
+          <a:prstGeom prst="roundRect">
+            <a:avLst>
+              <a:gd name="adj" fmla="val 3086"/>
+            </a:avLst>
+          </a:prstGeom>
+          <a:solidFill>
+            <a:srgbClr val="F5F7FB"/>
+          </a:solidFill>
+          <a:ln w="12700">
+            <a:solidFill>
+              <a:srgbClr val="FFFFFF"/>
+            </a:solidFill>
+            <a:prstDash val="solid"/>
+          </a:ln>
+        </p:spPr>
+      </p:sp>
+      <p:sp>
+        <p:nvSpPr>
+          <p:cNvPr id="12" name="Shape 8"/>
+          <p:cNvSpPr/>
+          <p:nvPr/>
+        </p:nvSpPr>
+        <p:spPr>
+          <a:xfrm>
+            <a:off x="6409944" y="5102352"/>
+            <a:ext cx="146304" cy="146304"/>
+          </a:xfrm>
+          <a:prstGeom prst="ellipse">
+            <a:avLst/>
+          </a:prstGeom>
+          <a:solidFill>
+            <a:srgbClr val="0F7B6C"/>
+          </a:solidFill>
+          <a:ln w="12700">
+            <a:solidFill>
+              <a:srgbClr val="0F7B6C"/>
+            </a:solidFill>
+            <a:prstDash val="solid"/>
+          </a:ln>
+        </p:spPr>
+      </p:sp>
+      <p:sp>
+        <p:nvSpPr>
+          <p:cNvPr id="13" name="Text 9"/>
+          <p:cNvSpPr txBox="1"/>
+          <p:nvPr/>
+        </p:nvSpPr>
+        <p:spPr>
+          <a:xfrm>
+            <a:off x="6665976" y="5001768"/>
+            <a:ext cx="4718304" cy="329184"/>
+          </a:xfrm>
+          <a:prstGeom prst="rect">
+            <a:avLst/>
+          </a:prstGeom>
+          <a:noFill/>
+          <a:ln/>
+        </p:spPr>
+        <p:txBody>
+          <a:bodyPr wrap="square" lIns="0" tIns="0" rIns="0" bIns="0" rtlCol="0" anchor="ctr"/>
+          <a:lstStyle/>
+          <a:p>
+            <a:pPr indent="0" marL="0">
+              <a:buNone/>
+            </a:pPr>
+            <a:r>
+              <a:rPr lang="en-US" sz="1450" b="1" dirty="0">
+                <a:solidFill>
+                  <a:srgbClr val="1E2761"/>
+                </a:solidFill>
+                <a:latin typeface="Calibri" pitchFamily="34" charset="0"/>
+                <a:ea typeface="Calibri" pitchFamily="34" charset="-122"/>
+                <a:cs typeface="Calibri" pitchFamily="34" charset="-120"/>
+              </a:rPr>
+              <a:t>配置對齊買到的是容錯，不是速度</a:t>
+            </a:r>
+            <a:endParaRPr lang="en-US" sz="1450" dirty="0"/>
+          </a:p>
+        </p:txBody>
+      </p:sp>
+      <p:sp>
+        <p:nvSpPr>
+          <p:cNvPr id="14" name="Text 10"/>
+          <p:cNvSpPr txBox="1"/>
+          <p:nvPr/>
+        </p:nvSpPr>
+        <p:spPr>
+          <a:xfrm>
+            <a:off x="6665976" y="5358384"/>
+            <a:ext cx="4718304" cy="877824"/>
+          </a:xfrm>
+          <a:prstGeom prst="rect">
+            <a:avLst/>
+          </a:prstGeom>
+          <a:noFill/>
+          <a:ln/>
+        </p:spPr>
+        <p:txBody>
+          <a:bodyPr wrap="square" lIns="0" tIns="0" rIns="0" bIns="0" rtlCol="0" anchor="ctr"/>
+          <a:lstStyle/>
+          <a:p>
+            <a:pPr marL="342900" indent="-342900">
+              <a:lnSpc>
+                <a:spcPts val="1800"/>
+              </a:lnSpc>
+              <a:spcAft>
+                <a:spcPts val="400"/>
+              </a:spcAft>
+              <a:buSzPct val="100000"/>
+              <a:buChar char="•"/>
+            </a:pPr>
+            <a:r>
+              <a:rPr lang="en-US" sz="1200" dirty="0">
+                <a:solidFill>
+                  <a:srgbClr val="16213E"/>
+                </a:solidFill>
+                <a:latin typeface="Calibri" pitchFamily="34" charset="0"/>
+                <a:ea typeface="Calibri" pitchFamily="34" charset="-122"/>
+                <a:cs typeface="Calibri" pitchFamily="34" charset="-120"/>
+              </a:rPr>
+              <a:t>最佳法則幾乎沒變：6.4 h → 6.6 h</a:t>
+            </a:r>
+            <a:endParaRPr lang="en-US" sz="1200" dirty="0"/>
+          </a:p>
+          <a:p>
+            <a:pPr marL="342900" indent="-342900">
+              <a:lnSpc>
+                <a:spcPts val="1800"/>
+              </a:lnSpc>
+              <a:spcAft>
+                <a:spcPts val="400"/>
+              </a:spcAft>
+              <a:buSzPct val="100000"/>
+              <a:buChar char="•"/>
+            </a:pPr>
+            <a:r>
+              <a:rPr lang="en-US" sz="1200" dirty="0">
+                <a:solidFill>
+                  <a:srgbClr val="16213E"/>
+                </a:solidFill>
+                <a:latin typeface="Calibri" pitchFamily="34" charset="0"/>
+                <a:ea typeface="Calibri" pitchFamily="34" charset="-122"/>
+                <a:cs typeface="Calibri" pitchFamily="34" charset="-120"/>
+              </a:rPr>
+              <a:t>最差法則大幅改善：19.8 h → 12.5 h</a:t>
+            </a:r>
+            <a:endParaRPr lang="en-US" sz="1200" dirty="0"/>
+          </a:p>
+          <a:p>
+            <a:pPr marL="342900" indent="-342900">
+              <a:lnSpc>
+                <a:spcPts val="1800"/>
+              </a:lnSpc>
+              <a:spcAft>
+                <a:spcPts val="400"/>
+              </a:spcAft>
+              <a:buSzPct val="100000"/>
+              <a:buChar char="•"/>
+            </a:pPr>
+            <a:r>
+              <a:rPr lang="en-US" sz="1200" dirty="0">
+                <a:solidFill>
+                  <a:srgbClr val="16213E"/>
+                </a:solidFill>
+                <a:latin typeface="Calibri" pitchFamily="34" charset="0"/>
+                <a:ea typeface="Calibri" pitchFamily="34" charset="-122"/>
+                <a:cs typeface="Calibri" pitchFamily="34" charset="-120"/>
+              </a:rPr>
+              <a:t>選錯法則的代價從 13.4 h 降到 5.9 h，等工程師歸零</a:t>
+            </a:r>
+            <a:endParaRPr lang="en-US" sz="1200" dirty="0"/>
+          </a:p>
+        </p:txBody>
+      </p:sp>
+      <p:sp>
+        <p:nvSpPr>
+          <p:cNvPr id="15" name="Text 11"/>
+          <p:cNvSpPr txBox="1"/>
+          <p:nvPr/>
+        </p:nvSpPr>
+        <p:spPr>
+          <a:xfrm>
+            <a:off x="566928" y="6382512"/>
+            <a:ext cx="11055096" cy="237744"/>
+          </a:xfrm>
+          <a:prstGeom prst="rect">
+            <a:avLst/>
+          </a:prstGeom>
+          <a:noFill/>
+          <a:ln/>
+        </p:spPr>
+        <p:txBody>
+          <a:bodyPr wrap="square" rtlCol="0" anchor="ctr"/>
+          <a:lstStyle/>
+          <a:p>
+            <a:pPr indent="0" marL="0">
+              <a:buNone/>
+            </a:pPr>
+            <a:r>
+              <a:rPr lang="en-US" sz="1000" dirty="0">
+                <a:solidFill>
+                  <a:srgbClr val="5A6785"/>
+                </a:solidFill>
+                <a:latin typeface="Calibri" pitchFamily="34" charset="0"/>
+                <a:ea typeface="Calibri" pitchFamily="34" charset="-122"/>
+                <a:cs typeface="Calibri" pitchFamily="34" charset="-120"/>
+              </a:rPr>
+              <a:t>註　這批 WIP 的 QFN32 佔 46.5% 工時，現場卻只有 5 台專用機（22 site）裝著它，QFN48 反而有 8 台（40 site）——配置和貨量是反的。「重新對齊」＝ 機台數與 site 結構完全不動，只改 20 台專用機各自綁哪一種封裝。</a:t>
+            </a:r>
+            <a:endParaRPr lang="en-US" sz="1000" dirty="0"/>
+          </a:p>
+        </p:txBody>
+      </p:sp>
+    </p:spTree>
+  </p:cSld>
+  <p:clrMapOvr>
+    <a:masterClrMapping/>
+  </p:clrMapOvr>
+</p:sld>
+</file>
+
+<file path=ppt/slides/slide13.xml><?xml version="1.0" encoding="utf-8"?>
+<p:sld xmlns:a="http://schemas.openxmlformats.org/drawingml/2006/main" xmlns:r="http://schemas.openxmlformats.org/officeDocument/2006/relationships" xmlns:p="http://schemas.openxmlformats.org/presentationml/2006/main">
+  <p:cSld name="Slide 13">
     <p:bg>
       <p:bgPr>
         <a:solidFill>
@@ -3394,7 +4082,7 @@
                 <a:ea typeface="Calibri" pitchFamily="34" charset="-122"/>
                 <a:cs typeface="Calibri" pitchFamily="34" charset="-120"/>
               </a:rPr>
-              <a:t>11</a:t>
+              <a:t>12</a:t>
             </a:r>
             <a:endParaRPr lang="en-US" sz="1300" dirty="0"/>
           </a:p>
@@ -4382,7 +5070,7 @@
                 <a:ea typeface="Calibri" pitchFamily="34" charset="-122"/>
                 <a:cs typeface="Calibri" pitchFamily="34" charset="-120"/>
               </a:rPr>
-              <a:t>但第 1 項有前提：省改機是「人力吃緊」時的最佳解。人補到 1:2.5 之後，改用「大批給快機」更快——夜班與白班人數不同，規則就該不同。</a:t>
+              <a:t>但第 1 項有前提：省改機是「人力吃緊、機台不夠」時的最佳解。人補到 1:2.5、或機台多到用不完時，改用「大批給快機」更快——班別與機隊狀況不同，規則就該不同。</a:t>
             </a:r>
             <a:endParaRPr lang="en-US" sz="1150" dirty="0"/>
           </a:p>
@@ -4396,9 +5084,9 @@
 </p:sld>
 </file>
 
-<file path=ppt/slides/slide13.xml><?xml version="1.0" encoding="utf-8"?>
+<file path=ppt/slides/slide14.xml><?xml version="1.0" encoding="utf-8"?>
 <p:sld xmlns:a="http://schemas.openxmlformats.org/drawingml/2006/main" xmlns:r="http://schemas.openxmlformats.org/officeDocument/2006/relationships" xmlns:p="http://schemas.openxmlformats.org/presentationml/2006/main">
-  <p:cSld name="Slide 13">
+  <p:cSld name="Slide 14">
     <p:spTree>
       <p:nvGrpSpPr>
         <p:cNvPr id="1" name=""/>
@@ -4446,7 +5134,7 @@
                 <a:ea typeface="Calibri" pitchFamily="34" charset="-122"/>
                 <a:cs typeface="Calibri" pitchFamily="34" charset="-120"/>
               </a:rPr>
-              <a:t>12</a:t>
+              <a:t>13</a:t>
             </a:r>
             <a:endParaRPr lang="en-US" sz="1300" dirty="0"/>
           </a:p>

</xml_diff>

<commit_message>
Add a measurable rule for switching scheduling policy
The report now shows four reversals of which rule wins without saying
how a scheduler is meant to tell which situation they are in. This puts
all ten runs on one scale: changeover plus engineer waiting as a share
of machine time, measured on the floor's current earliest-due schedule.
Above about 33% minimising changeovers wins, below it routing big lots
to the fast machines does, and the split is clean across all ten.

Both terms are needed. On five machines changeover alone eats 35% while
waiting is near zero; on twenty-five machines with three engineers it is
the other way round, waiting 36% against changeover 10%. Either number
on its own misclassifies half the cases.

The recommendation slide's caveat and the week-9 tracking metric now
point at this number instead of describing the situation in words.

Co-Authored-By: Claude Opus 5 <noreply@anthropic.com>
Claude-Session: https://claude.ai/code/session_01TrwTqMZ3kHRLL23LGZ4TZk
</commit_message>
<xml_diff>
--- a/docs/測試排程分析報告.pptx
+++ b/docs/測試排程分析報告.pptx
@@ -19,9 +19,10 @@
     <p:sldId id="267" r:id="rId13"/>
     <p:sldId id="268" r:id="rId14"/>
     <p:sldId id="269" r:id="rId15"/>
+    <p:sldId id="270" r:id="rId16"/>
   </p:sldIdLst>
   <p:notesMasterIdLst>
-    <p:notesMasterId r:id="rId16"/>
+    <p:notesMasterId r:id="rId17"/>
   </p:notesMasterIdLst>
   <p:sldSz cx="12192000" cy="6858000"/>
   <p:notesSz cx="6858000" cy="12192000"/>
@@ -867,7 +868,7 @@
           <a:p>
             <a:r>
               <a:rPr lang="en-US" dirty="0"/>
-              <a:t>前兩項是純管理決策，今天就能改；第三項是人力預算；第四項需要 IT 或設備工程投入。</a:t>
+              <a:t>門檻的實際分界在 31.7% 與 35.8% 之間；靠近門檻時兩種法則差距小，選錯的代價不大。</a:t>
             </a:r>
             <a:endParaRPr lang="en-US" dirty="0"/>
           </a:p>
@@ -955,7 +956,7 @@
           <a:p>
             <a:r>
               <a:rPr lang="en-US" dirty="0"/>
-              <a:t>四個階段刻意分開，避免同時變動多個變數而無法歸因。最大的單一不確定性是換程式是否佔用工程師。</a:t>
+              <a:t>前兩項是純管理決策，今天就能改；第三項是人力預算；第四項需要 IT 或設備工程投入。</a:t>
             </a:r>
             <a:endParaRPr lang="en-US" dirty="0"/>
           </a:p>
@@ -979,6 +980,94 @@
             <a:fld id="{F7021451-1387-4CA6-816F-3879F97B5CBC}" type="slidenum">
               <a:rPr lang="en-US"/>
               <a:t>14</a:t>
+            </a:fld>
+            <a:endParaRPr lang="en-US"/>
+          </a:p>
+        </p:txBody>
+      </p:sp>
+    </p:spTree>
+    <p:extLst>
+      <p:ext uri="{BB962C8B-B14F-4D97-AF65-F5344CB8AC3E}">
+        <p14:creationId xmlns:p14="http://schemas.microsoft.com/office/powerpoint/2010/main" val="1024086991"/>
+      </p:ext>
+    </p:extLst>
+  </p:cSld>
+  <p:clrMapOvr>
+    <a:masterClrMapping/>
+  </p:clrMapOvr>
+</p:notes>
+</file>
+
+<file path=ppt/notesSlides/notesSlide15.xml><?xml version="1.0" encoding="utf-8"?>
+<p:notes xmlns:a="http://schemas.openxmlformats.org/drawingml/2006/main" xmlns:r="http://schemas.openxmlformats.org/officeDocument/2006/relationships" xmlns:p="http://schemas.openxmlformats.org/presentationml/2006/main">
+  <p:cSld>
+    <p:spTree>
+      <p:nvGrpSpPr>
+        <p:cNvPr id="1" name=""/>
+        <p:cNvGrpSpPr/>
+        <p:nvPr/>
+      </p:nvGrpSpPr>
+      <p:grpSpPr>
+        <a:xfrm>
+          <a:off x="0" y="0"/>
+          <a:ext cx="0" cy="0"/>
+          <a:chOff x="0" y="0"/>
+          <a:chExt cx="0" cy="0"/>
+        </a:xfrm>
+      </p:grpSpPr>
+      <p:sp>
+        <p:nvSpPr>
+          <p:cNvPr id="2" name="Slide Image Placeholder 1"/>
+          <p:cNvSpPr>
+            <a:spLocks noGrp="1" noRot="1" noChangeAspect="1"/>
+          </p:cNvSpPr>
+          <p:nvPr>
+            <p:ph type="sldImg"/>
+          </p:nvPr>
+        </p:nvSpPr>
+        <p:spPr/>
+      </p:sp>
+      <p:sp>
+        <p:nvSpPr>
+          <p:cNvPr id="3" name="Notes Placeholder 2"/>
+          <p:cNvSpPr>
+            <a:spLocks noGrp="1"/>
+          </p:cNvSpPr>
+          <p:nvPr>
+            <p:ph type="body" idx="1"/>
+          </p:nvPr>
+        </p:nvSpPr>
+        <p:spPr/>
+        <p:txBody>
+          <a:bodyPr/>
+          <a:lstStyle/>
+          <a:p>
+            <a:r>
+              <a:rPr lang="en-US" dirty="0"/>
+              <a:t>四個階段刻意分開，避免同時變動多個變數而無法歸因。最大的單一不確定性是換程式是否佔用工程師。</a:t>
+            </a:r>
+            <a:endParaRPr lang="en-US" dirty="0"/>
+          </a:p>
+        </p:txBody>
+      </p:sp>
+      <p:sp>
+        <p:nvSpPr>
+          <p:cNvPr id="4" name="Slide Number Placeholder 3"/>
+          <p:cNvSpPr>
+            <a:spLocks noGrp="1"/>
+          </p:cNvSpPr>
+          <p:nvPr>
+            <p:ph type="sldNum" sz="quarter" idx="10"/>
+          </p:nvPr>
+        </p:nvSpPr>
+        <p:spPr/>
+        <p:txBody>
+          <a:bodyPr/>
+          <a:lstStyle/>
+          <a:p>
+            <a:fld id="{F7021451-1387-4CA6-816F-3879F97B5CBC}" type="slidenum">
+              <a:rPr lang="en-US"/>
+              <a:t>15</a:t>
             </a:fld>
             <a:endParaRPr lang="en-US"/>
           </a:p>
@@ -4028,6 +4117,533 @@
 <file path=ppt/slides/slide13.xml><?xml version="1.0" encoding="utf-8"?>
 <p:sld xmlns:a="http://schemas.openxmlformats.org/drawingml/2006/main" xmlns:r="http://schemas.openxmlformats.org/officeDocument/2006/relationships" xmlns:p="http://schemas.openxmlformats.org/presentationml/2006/main">
   <p:cSld name="Slide 13">
+    <p:spTree>
+      <p:nvGrpSpPr>
+        <p:cNvPr id="1" name=""/>
+        <p:cNvGrpSpPr/>
+        <p:nvPr/>
+      </p:nvGrpSpPr>
+      <p:grpSpPr>
+        <a:xfrm>
+          <a:off x="0" y="0"/>
+          <a:ext cx="0" cy="0"/>
+          <a:chOff x="0" y="0"/>
+          <a:chExt cx="0" cy="0"/>
+        </a:xfrm>
+      </p:grpSpPr>
+      <p:sp>
+        <p:nvSpPr>
+          <p:cNvPr id="2" name="Text 0"/>
+          <p:cNvSpPr txBox="1"/>
+          <p:nvPr/>
+        </p:nvSpPr>
+        <p:spPr>
+          <a:xfrm>
+            <a:off x="566928" y="384048"/>
+            <a:ext cx="502920" cy="457200"/>
+          </a:xfrm>
+          <a:prstGeom prst="rect">
+            <a:avLst/>
+          </a:prstGeom>
+          <a:noFill/>
+          <a:ln/>
+        </p:spPr>
+        <p:txBody>
+          <a:bodyPr wrap="square" rtlCol="0" anchor="ctr"/>
+          <a:lstStyle/>
+          <a:p>
+            <a:pPr indent="0" marL="0">
+              <a:buNone/>
+            </a:pPr>
+            <a:r>
+              <a:rPr lang="en-US" sz="1300" b="1" dirty="0">
+                <a:solidFill>
+                  <a:srgbClr val="1C7293"/>
+                </a:solidFill>
+                <a:latin typeface="Calibri" pitchFamily="34" charset="0"/>
+                <a:ea typeface="Calibri" pitchFamily="34" charset="-122"/>
+                <a:cs typeface="Calibri" pitchFamily="34" charset="-120"/>
+              </a:rPr>
+              <a:t>12</a:t>
+            </a:r>
+            <a:endParaRPr lang="en-US" sz="1300" dirty="0"/>
+          </a:p>
+        </p:txBody>
+      </p:sp>
+      <p:sp>
+        <p:nvSpPr>
+          <p:cNvPr id="3" name="Text 1"/>
+          <p:cNvSpPr txBox="1"/>
+          <p:nvPr/>
+        </p:nvSpPr>
+        <p:spPr>
+          <a:xfrm>
+            <a:off x="1143000" y="310896"/>
+            <a:ext cx="10424160" cy="566928"/>
+          </a:xfrm>
+          <a:prstGeom prst="rect">
+            <a:avLst/>
+          </a:prstGeom>
+          <a:noFill/>
+          <a:ln/>
+        </p:spPr>
+        <p:txBody>
+          <a:bodyPr wrap="square" rtlCol="0" anchor="ctr"/>
+          <a:lstStyle/>
+          <a:p>
+            <a:pPr indent="0" marL="0">
+              <a:buNone/>
+            </a:pPr>
+            <a:r>
+              <a:rPr lang="en-US" sz="3000" b="1" dirty="0">
+                <a:solidFill>
+                  <a:srgbClr val="1E2761"/>
+                </a:solidFill>
+                <a:latin typeface="Cambria" pitchFamily="34" charset="0"/>
+                <a:ea typeface="Cambria" pitchFamily="34" charset="-122"/>
+                <a:cs typeface="Cambria" pitchFamily="34" charset="-120"/>
+              </a:rPr>
+              <a:t>什麼時候該切換排程法則</a:t>
+            </a:r>
+            <a:endParaRPr lang="en-US" sz="3000" dirty="0"/>
+          </a:p>
+        </p:txBody>
+      </p:sp>
+      <p:sp>
+        <p:nvSpPr>
+          <p:cNvPr id="4" name="Text 2"/>
+          <p:cNvSpPr txBox="1"/>
+          <p:nvPr/>
+        </p:nvSpPr>
+        <p:spPr>
+          <a:xfrm>
+            <a:off x="1143000" y="896112"/>
+            <a:ext cx="10424160" cy="384048"/>
+          </a:xfrm>
+          <a:prstGeom prst="rect">
+            <a:avLst/>
+          </a:prstGeom>
+          <a:noFill/>
+          <a:ln/>
+        </p:spPr>
+        <p:txBody>
+          <a:bodyPr wrap="square" rtlCol="0" anchor="ctr"/>
+          <a:lstStyle/>
+          <a:p>
+            <a:pPr indent="0" marL="0">
+              <a:buNone/>
+            </a:pPr>
+            <a:r>
+              <a:rPr lang="en-US" sz="1350" dirty="0">
+                <a:solidFill>
+                  <a:srgbClr val="5A6785"/>
+                </a:solidFill>
+                <a:latin typeface="Calibri" pitchFamily="34" charset="0"/>
+                <a:ea typeface="Calibri" pitchFamily="34" charset="-122"/>
+                <a:cs typeface="Calibri" pitchFamily="34" charset="-120"/>
+              </a:rPr>
+              <a:t>四次翻轉放在同一把尺上量：改機與等工程師合計吃掉多少機台時間，門檻落在 33% 附近</a:t>
+            </a:r>
+            <a:endParaRPr lang="en-US" sz="1350" dirty="0"/>
+          </a:p>
+        </p:txBody>
+      </p:sp>
+      <p:pic>
+        <p:nvPicPr>
+          <p:cNvPr id="5" name="Image 0" descr="charts/c_switch.png">    </p:cNvPr>
+          <p:cNvPicPr>
+            <a:picLocks noChangeAspect="1"/>
+          </p:cNvPicPr>
+          <p:nvPr/>
+        </p:nvPicPr>
+        <p:blipFill>
+          <a:blip r:embed="rId1"/>
+          <a:stretch>
+            <a:fillRect/>
+          </a:stretch>
+        </p:blipFill>
+        <p:spPr>
+          <a:xfrm>
+            <a:off x="1344168" y="1280160"/>
+            <a:ext cx="9509760" cy="3929003"/>
+          </a:xfrm>
+          <a:prstGeom prst="rect">
+            <a:avLst/>
+          </a:prstGeom>
+        </p:spPr>
+      </p:pic>
+      <p:sp>
+        <p:nvSpPr>
+          <p:cNvPr id="6" name="Shape 3"/>
+          <p:cNvSpPr/>
+          <p:nvPr/>
+        </p:nvSpPr>
+        <p:spPr>
+          <a:xfrm>
+            <a:off x="566928" y="5285232"/>
+            <a:ext cx="5486400" cy="1188720"/>
+          </a:xfrm>
+          <a:prstGeom prst="roundRect">
+            <a:avLst>
+              <a:gd name="adj" fmla="val 3846"/>
+            </a:avLst>
+          </a:prstGeom>
+          <a:solidFill>
+            <a:srgbClr val="F5F7FB"/>
+          </a:solidFill>
+          <a:ln w="12700">
+            <a:solidFill>
+              <a:srgbClr val="FFFFFF"/>
+            </a:solidFill>
+            <a:prstDash val="solid"/>
+          </a:ln>
+        </p:spPr>
+      </p:sp>
+      <p:sp>
+        <p:nvSpPr>
+          <p:cNvPr id="7" name="Shape 4"/>
+          <p:cNvSpPr/>
+          <p:nvPr/>
+        </p:nvSpPr>
+        <p:spPr>
+          <a:xfrm>
+            <a:off x="804672" y="5541264"/>
+            <a:ext cx="146304" cy="146304"/>
+          </a:xfrm>
+          <a:prstGeom prst="ellipse">
+            <a:avLst/>
+          </a:prstGeom>
+          <a:solidFill>
+            <a:srgbClr val="1E2761"/>
+          </a:solidFill>
+          <a:ln w="12700">
+            <a:solidFill>
+              <a:srgbClr val="1E2761"/>
+            </a:solidFill>
+            <a:prstDash val="solid"/>
+          </a:ln>
+        </p:spPr>
+      </p:sp>
+      <p:sp>
+        <p:nvSpPr>
+          <p:cNvPr id="8" name="Text 5"/>
+          <p:cNvSpPr txBox="1"/>
+          <p:nvPr/>
+        </p:nvSpPr>
+        <p:spPr>
+          <a:xfrm>
+            <a:off x="1060704" y="5440680"/>
+            <a:ext cx="4754880" cy="329184"/>
+          </a:xfrm>
+          <a:prstGeom prst="rect">
+            <a:avLst/>
+          </a:prstGeom>
+          <a:noFill/>
+          <a:ln/>
+        </p:spPr>
+        <p:txBody>
+          <a:bodyPr wrap="square" lIns="0" tIns="0" rIns="0" bIns="0" rtlCol="0" anchor="ctr"/>
+          <a:lstStyle/>
+          <a:p>
+            <a:pPr indent="0" marL="0">
+              <a:buNone/>
+            </a:pPr>
+            <a:r>
+              <a:rPr lang="en-US" sz="1450" b="1" dirty="0">
+                <a:solidFill>
+                  <a:srgbClr val="1E2761"/>
+                </a:solidFill>
+                <a:latin typeface="Calibri" pitchFamily="34" charset="0"/>
+                <a:ea typeface="Calibri" pitchFamily="34" charset="-122"/>
+                <a:cs typeface="Calibri" pitchFamily="34" charset="-120"/>
+              </a:rPr>
+              <a:t>怎麼量（用現場的實績，不用模擬）</a:t>
+            </a:r>
+            <a:endParaRPr lang="en-US" sz="1450" dirty="0"/>
+          </a:p>
+        </p:txBody>
+      </p:sp>
+      <p:sp>
+        <p:nvSpPr>
+          <p:cNvPr id="9" name="Text 6"/>
+          <p:cNvSpPr txBox="1"/>
+          <p:nvPr/>
+        </p:nvSpPr>
+        <p:spPr>
+          <a:xfrm>
+            <a:off x="1060704" y="5797296"/>
+            <a:ext cx="4754880" cy="585216"/>
+          </a:xfrm>
+          <a:prstGeom prst="rect">
+            <a:avLst/>
+          </a:prstGeom>
+          <a:noFill/>
+          <a:ln/>
+        </p:spPr>
+        <p:txBody>
+          <a:bodyPr wrap="square" lIns="0" tIns="0" rIns="0" bIns="0" rtlCol="0" anchor="ctr"/>
+          <a:lstStyle/>
+          <a:p>
+            <a:pPr marL="342900" indent="-342900">
+              <a:lnSpc>
+                <a:spcPts val="1800"/>
+              </a:lnSpc>
+              <a:spcAft>
+                <a:spcPts val="400"/>
+              </a:spcAft>
+              <a:buSzPct val="100000"/>
+              <a:buChar char="•"/>
+            </a:pPr>
+            <a:r>
+              <a:rPr lang="en-US" sz="1200" dirty="0">
+                <a:solidFill>
+                  <a:srgbClr val="16213E"/>
+                </a:solidFill>
+                <a:latin typeface="Calibri" pitchFamily="34" charset="0"/>
+                <a:ea typeface="Calibri" pitchFamily="34" charset="-122"/>
+                <a:cs typeface="Calibri" pitchFamily="34" charset="-120"/>
+              </a:rPr>
+              <a:t>（改機分鐘 ＋ 等工程師分鐘）÷（機台數 × 當班分鐘）</a:t>
+            </a:r>
+            <a:endParaRPr lang="en-US" sz="1200" dirty="0"/>
+          </a:p>
+          <a:p>
+            <a:pPr marL="342900" indent="-342900">
+              <a:lnSpc>
+                <a:spcPts val="1800"/>
+              </a:lnSpc>
+              <a:spcAft>
+                <a:spcPts val="400"/>
+              </a:spcAft>
+              <a:buSzPct val="100000"/>
+              <a:buChar char="•"/>
+            </a:pPr>
+            <a:r>
+              <a:rPr lang="en-US" sz="1200" dirty="0">
+                <a:solidFill>
+                  <a:srgbClr val="16213E"/>
+                </a:solidFill>
+                <a:latin typeface="Calibri" pitchFamily="34" charset="0"/>
+                <a:ea typeface="Calibri" pitchFamily="34" charset="-122"/>
+                <a:cs typeface="Calibri" pitchFamily="34" charset="-120"/>
+              </a:rPr>
+              <a:t>模擬器的跑分表直接有這兩欄，現場的機台稼動報表也有</a:t>
+            </a:r>
+            <a:endParaRPr lang="en-US" sz="1200" dirty="0"/>
+          </a:p>
+        </p:txBody>
+      </p:sp>
+      <p:sp>
+        <p:nvSpPr>
+          <p:cNvPr id="10" name="Shape 7"/>
+          <p:cNvSpPr/>
+          <p:nvPr/>
+        </p:nvSpPr>
+        <p:spPr>
+          <a:xfrm>
+            <a:off x="6172200" y="5285232"/>
+            <a:ext cx="5449824" cy="1188720"/>
+          </a:xfrm>
+          <a:prstGeom prst="roundRect">
+            <a:avLst>
+              <a:gd name="adj" fmla="val 3846"/>
+            </a:avLst>
+          </a:prstGeom>
+          <a:solidFill>
+            <a:srgbClr val="F5F7FB"/>
+          </a:solidFill>
+          <a:ln w="12700">
+            <a:solidFill>
+              <a:srgbClr val="FFFFFF"/>
+            </a:solidFill>
+            <a:prstDash val="solid"/>
+          </a:ln>
+        </p:spPr>
+      </p:sp>
+      <p:sp>
+        <p:nvSpPr>
+          <p:cNvPr id="11" name="Shape 8"/>
+          <p:cNvSpPr/>
+          <p:nvPr/>
+        </p:nvSpPr>
+        <p:spPr>
+          <a:xfrm>
+            <a:off x="6409944" y="5541264"/>
+            <a:ext cx="146304" cy="146304"/>
+          </a:xfrm>
+          <a:prstGeom prst="ellipse">
+            <a:avLst/>
+          </a:prstGeom>
+          <a:solidFill>
+            <a:srgbClr val="0F7B6C"/>
+          </a:solidFill>
+          <a:ln w="12700">
+            <a:solidFill>
+              <a:srgbClr val="0F7B6C"/>
+            </a:solidFill>
+            <a:prstDash val="solid"/>
+          </a:ln>
+        </p:spPr>
+      </p:sp>
+      <p:sp>
+        <p:nvSpPr>
+          <p:cNvPr id="12" name="Text 9"/>
+          <p:cNvSpPr txBox="1"/>
+          <p:nvPr/>
+        </p:nvSpPr>
+        <p:spPr>
+          <a:xfrm>
+            <a:off x="6665976" y="5440680"/>
+            <a:ext cx="4718304" cy="329184"/>
+          </a:xfrm>
+          <a:prstGeom prst="rect">
+            <a:avLst/>
+          </a:prstGeom>
+          <a:noFill/>
+          <a:ln/>
+        </p:spPr>
+        <p:txBody>
+          <a:bodyPr wrap="square" lIns="0" tIns="0" rIns="0" bIns="0" rtlCol="0" anchor="ctr"/>
+          <a:lstStyle/>
+          <a:p>
+            <a:pPr indent="0" marL="0">
+              <a:buNone/>
+            </a:pPr>
+            <a:r>
+              <a:rPr lang="en-US" sz="1450" b="1" dirty="0">
+                <a:solidFill>
+                  <a:srgbClr val="1E2761"/>
+                </a:solidFill>
+                <a:latin typeface="Calibri" pitchFamily="34" charset="0"/>
+                <a:ea typeface="Calibri" pitchFamily="34" charset="-122"/>
+                <a:cs typeface="Calibri" pitchFamily="34" charset="-120"/>
+              </a:rPr>
+              <a:t>怎麼判斷</a:t>
+            </a:r>
+            <a:endParaRPr lang="en-US" sz="1450" dirty="0"/>
+          </a:p>
+        </p:txBody>
+      </p:sp>
+      <p:sp>
+        <p:nvSpPr>
+          <p:cNvPr id="13" name="Text 10"/>
+          <p:cNvSpPr txBox="1"/>
+          <p:nvPr/>
+        </p:nvSpPr>
+        <p:spPr>
+          <a:xfrm>
+            <a:off x="6665976" y="5797296"/>
+            <a:ext cx="4718304" cy="585216"/>
+          </a:xfrm>
+          <a:prstGeom prst="rect">
+            <a:avLst/>
+          </a:prstGeom>
+          <a:noFill/>
+          <a:ln/>
+        </p:spPr>
+        <p:txBody>
+          <a:bodyPr wrap="square" lIns="0" tIns="0" rIns="0" bIns="0" rtlCol="0" anchor="ctr"/>
+          <a:lstStyle/>
+          <a:p>
+            <a:pPr marL="342900" indent="-342900">
+              <a:lnSpc>
+                <a:spcPts val="1800"/>
+              </a:lnSpc>
+              <a:spcAft>
+                <a:spcPts val="400"/>
+              </a:spcAft>
+              <a:buSzPct val="100000"/>
+              <a:buChar char="•"/>
+            </a:pPr>
+            <a:r>
+              <a:rPr lang="en-US" sz="1200" dirty="0">
+                <a:solidFill>
+                  <a:srgbClr val="16213E"/>
+                </a:solidFill>
+                <a:latin typeface="Calibri" pitchFamily="34" charset="0"/>
+                <a:ea typeface="Calibri" pitchFamily="34" charset="-122"/>
+                <a:cs typeface="Calibri" pitchFamily="34" charset="-120"/>
+              </a:rPr>
+              <a:t>超過 35% → 改用「省改機優先」，10 組情境全對</a:t>
+            </a:r>
+            <a:endParaRPr lang="en-US" sz="1200" dirty="0"/>
+          </a:p>
+          <a:p>
+            <a:pPr marL="342900" indent="-342900">
+              <a:lnSpc>
+                <a:spcPts val="1800"/>
+              </a:lnSpc>
+              <a:spcAft>
+                <a:spcPts val="400"/>
+              </a:spcAft>
+              <a:buSzPct val="100000"/>
+              <a:buChar char="•"/>
+            </a:pPr>
+            <a:r>
+              <a:rPr lang="en-US" sz="1200" dirty="0">
+                <a:solidFill>
+                  <a:srgbClr val="16213E"/>
+                </a:solidFill>
+                <a:latin typeface="Calibri" pitchFamily="34" charset="0"/>
+                <a:ea typeface="Calibri" pitchFamily="34" charset="-122"/>
+                <a:cs typeface="Calibri" pitchFamily="34" charset="-120"/>
+              </a:rPr>
+              <a:t>低於 30% → 改用「大批給快機」；30～35% 之間兩者差不到 15%</a:t>
+            </a:r>
+            <a:endParaRPr lang="en-US" sz="1200" dirty="0"/>
+          </a:p>
+        </p:txBody>
+      </p:sp>
+      <p:sp>
+        <p:nvSpPr>
+          <p:cNvPr id="14" name="Text 11"/>
+          <p:cNvSpPr txBox="1"/>
+          <p:nvPr/>
+        </p:nvSpPr>
+        <p:spPr>
+          <a:xfrm>
+            <a:off x="566928" y="6492240"/>
+            <a:ext cx="11055096" cy="173736"/>
+          </a:xfrm>
+          <a:prstGeom prst="rect">
+            <a:avLst/>
+          </a:prstGeom>
+          <a:noFill/>
+          <a:ln/>
+        </p:spPr>
+        <p:txBody>
+          <a:bodyPr wrap="square" rtlCol="0" anchor="ctr"/>
+          <a:lstStyle/>
+          <a:p>
+            <a:pPr indent="0" marL="0">
+              <a:buNone/>
+            </a:pPr>
+            <a:r>
+              <a:rPr lang="en-US" sz="950" dirty="0">
+                <a:solidFill>
+                  <a:srgbClr val="5A6785"/>
+                </a:solidFill>
+                <a:latin typeface="Calibri" pitchFamily="34" charset="0"/>
+                <a:ea typeface="Calibri" pitchFamily="34" charset="-122"/>
+                <a:cs typeface="Calibri" pitchFamily="34" charset="-120"/>
+              </a:rPr>
+              <a:t>註　兩項要合計才準：5 台機那三組是改機本身吃掉 35%（等人只有 0～2%），25 台機 200 批 3 人那組反過來是等人吃掉 36%（改機只有 10%）——只看其中一項都會判錯。量測時用現行的「追交期」排程當基準。</a:t>
+            </a:r>
+            <a:endParaRPr lang="en-US" sz="950" dirty="0"/>
+          </a:p>
+        </p:txBody>
+      </p:sp>
+    </p:spTree>
+  </p:cSld>
+  <p:clrMapOvr>
+    <a:masterClrMapping/>
+  </p:clrMapOvr>
+</p:sld>
+</file>
+
+<file path=ppt/slides/slide14.xml><?xml version="1.0" encoding="utf-8"?>
+<p:sld xmlns:a="http://schemas.openxmlformats.org/drawingml/2006/main" xmlns:r="http://schemas.openxmlformats.org/officeDocument/2006/relationships" xmlns:p="http://schemas.openxmlformats.org/presentationml/2006/main">
+  <p:cSld name="Slide 14">
     <p:bg>
       <p:bgPr>
         <a:solidFill>
@@ -4082,7 +4698,7 @@
                 <a:ea typeface="Calibri" pitchFamily="34" charset="-122"/>
                 <a:cs typeface="Calibri" pitchFamily="34" charset="-120"/>
               </a:rPr>
-              <a:t>12</a:t>
+              <a:t>13</a:t>
             </a:r>
             <a:endParaRPr lang="en-US" sz="1300" dirty="0"/>
           </a:p>
@@ -5070,7 +5686,7 @@
                 <a:ea typeface="Calibri" pitchFamily="34" charset="-122"/>
                 <a:cs typeface="Calibri" pitchFamily="34" charset="-120"/>
               </a:rPr>
-              <a:t>但第 1 項有前提：省改機是「人力吃緊、機台不夠」時的最佳解。人補到 1:2.5、或機台多到用不完時，改用「大批給快機」更快——班別與機隊狀況不同，規則就該不同。</a:t>
+              <a:t>但第 1 項有前提：省改機是「改機＋等工程師吃掉機台時間超過 35%」時的最佳解；低於 30% 就該改用「大批給快機」（見第 12 頁）。班別與機隊狀況不同，規則就該不同。</a:t>
             </a:r>
             <a:endParaRPr lang="en-US" sz="1150" dirty="0"/>
           </a:p>
@@ -5084,9 +5700,9 @@
 </p:sld>
 </file>
 
-<file path=ppt/slides/slide14.xml><?xml version="1.0" encoding="utf-8"?>
+<file path=ppt/slides/slide15.xml><?xml version="1.0" encoding="utf-8"?>
 <p:sld xmlns:a="http://schemas.openxmlformats.org/drawingml/2006/main" xmlns:r="http://schemas.openxmlformats.org/officeDocument/2006/relationships" xmlns:p="http://schemas.openxmlformats.org/presentationml/2006/main">
-  <p:cSld name="Slide 14">
+  <p:cSld name="Slide 15">
     <p:spTree>
       <p:nvGrpSpPr>
         <p:cNvPr id="1" name=""/>
@@ -5134,7 +5750,7 @@
                 <a:ea typeface="Calibri" pitchFamily="34" charset="-122"/>
                 <a:cs typeface="Calibri" pitchFamily="34" charset="-120"/>
               </a:rPr>
-              <a:t>13</a:t>
+              <a:t>14</a:t>
             </a:r>
             <a:endParaRPr lang="en-US" sz="1300" dirty="0"/>
           </a:p>
@@ -6224,7 +6840,7 @@
                 <a:ea typeface="Calibri" pitchFamily="34" charset="-122"/>
                 <a:cs typeface="Calibri" pitchFamily="34" charset="-120"/>
               </a:rPr>
-              <a:t>追蹤：換程式次數 × 平均時間</a:t>
+              <a:t>追蹤：（改機＋等人）÷ 機台時間</a:t>
             </a:r>
             <a:endParaRPr lang="en-US" sz="1100" dirty="0"/>
           </a:p>

</xml_diff>